<commit_message>
content: align ERS and OIB checkpoints with exercises 4 and 8
</commit_message>
<xml_diff>
--- a/01 Elementi Razvoja Softvera/02 Prezentacije/PPTX/01 Захтеви, backlog, Git и тимски развој.pptx
+++ b/01 Elementi Razvoja Softvera/02 Prezentacije/PPTX/01 Захтеви, backlog, Git и тимски развој.pptx
@@ -2693,7 +2693,7 @@
 </file>
 
 <file path=ppt/notesSlides/notesSlide32.xml><?xml version="1.0" encoding="utf-8"?>
-<p:notes xmlns:a="http://schemas.openxmlformats.org/drawingml/2006/main" xmlns:r="http://schemas.openxmlformats.org/officeDocument/2006/relationships" xmlns:p="http://schemas.openxmlformats.org/presentationml/2006/main">
+<p:notes xmlns:p="http://schemas.openxmlformats.org/presentationml/2006/main">
   <p:cSld>
     <p:spTree>
       <p:nvGrpSpPr>
@@ -2702,21 +2702,16 @@
         <p:nvPr/>
       </p:nvGrpSpPr>
       <p:grpSpPr>
-        <a:xfrm>
-          <a:off x="0" y="0"/>
-          <a:ext cx="0" cy="0"/>
-          <a:chOff x="0" y="0"/>
-          <a:chExt cx="0" cy="0"/>
-        </a:xfrm>
+        <a:xfrm xmlns:a="http://schemas.openxmlformats.org/drawingml/2006/main"/>
       </p:grpSpPr>
       <p:sp>
         <p:nvSpPr>
           <p:cNvPr id="2" name="Slide Image Placeholder 1"/>
           <p:cNvSpPr>
-            <a:spLocks noGrp="1" noRot="1" noChangeAspect="1"/>
+            <a:spLocks xmlns:a="http://schemas.openxmlformats.org/drawingml/2006/main" noGrp="1"/>
           </p:cNvSpPr>
           <p:nvPr>
-            <p:ph type="sldImg"/>
+            <p:ph type="sldImg" idx="0"/>
           </p:nvPr>
         </p:nvSpPr>
         <p:spPr/>
@@ -2725,7 +2720,7 @@
         <p:nvSpPr>
           <p:cNvPr id="3" name="Notes Placeholder 2"/>
           <p:cNvSpPr>
-            <a:spLocks noGrp="1"/>
+            <a:spLocks xmlns:a="http://schemas.openxmlformats.org/drawingml/2006/main" noGrp="1"/>
           </p:cNvSpPr>
           <p:nvPr>
             <p:ph type="body" idx="1"/>
@@ -2733,14 +2728,13 @@
         </p:nvSpPr>
         <p:spPr/>
         <p:txBody>
-          <a:bodyPr/>
-          <a:lstStyle/>
-          <a:p>
-            <a:r>
-              <a:rPr lang="en-US" dirty="0"/>
-              <a:t>Прва контролна тачка је после друге вежбе, у недељи од 19. октобра, и носи три поена. Проверава се да ли репозиторијум постоји, има README и да ли сви чланови тима имају приступ, да ли је backlog у алату Tapiz Boards са приоритетима и критеријумима прихватања, да ли постоји бар један Pull Request са прегледом и образложеним коментарима и да ли тим има договорен ток рада од backlog-а до завршене ставке.</a:t>
-            </a:r>
-            <a:endParaRPr lang="en-US" dirty="0"/>
+          <a:bodyPr xmlns:a="http://schemas.openxmlformats.org/drawingml/2006/main"/>
+          <a:lstStyle xmlns:a="http://schemas.openxmlformats.org/drawingml/2006/main"/>
+          <a:p xmlns:a="http://schemas.openxmlformats.org/drawingml/2006/main">
+            <a:r>
+              <a:t>Прва контролна тачка је у термину четврте вежбе и носи највише 10 поена. Поред организације рада, приказују се основни доменски модел и границе свих додељених целина, најмање један извршив функционални ток и аутоматизовани тест значајног правила. Проверава се да ли репозиторијум постоји, има README и да ли сви чланови тима имају приступ, да ли је backlog у алату Tapiz Boards са приоритетима и критеријумима прихватања, да ли постоји бар један Pull Request са прегледом и образложеним коментарима и да ли тим има договорен ток рада од backlog-а до завршене ставке.</a:t>
+            </a:r>
+            <a:endParaRPr/>
           </a:p>
         </p:txBody>
       </p:sp>
@@ -2748,34 +2742,23 @@
         <p:nvSpPr>
           <p:cNvPr id="4" name="Slide Number Placeholder 3"/>
           <p:cNvSpPr>
-            <a:spLocks noGrp="1"/>
+            <a:spLocks xmlns:a="http://schemas.openxmlformats.org/drawingml/2006/main" noGrp="1"/>
           </p:cNvSpPr>
           <p:nvPr>
-            <p:ph type="sldNum" sz="quarter" idx="10"/>
+            <p:ph type="sldNum" idx="5"/>
           </p:nvPr>
         </p:nvSpPr>
         <p:spPr/>
         <p:txBody>
-          <a:bodyPr/>
-          <a:lstStyle/>
-          <a:p>
-            <a:fld id="{F7021451-1387-4CA6-816F-3879F97B5CBC}" type="slidenum">
-              <a:rPr lang="en-US"/>
-              <a:t>32</a:t>
-            </a:fld>
-            <a:endParaRPr lang="en-US"/>
-          </a:p>
+          <a:bodyPr xmlns:a="http://schemas.openxmlformats.org/drawingml/2006/main"/>
+          <a:lstStyle xmlns:a="http://schemas.openxmlformats.org/drawingml/2006/main"/>
+          <a:p xmlns:a="http://schemas.openxmlformats.org/drawingml/2006/main"/>
         </p:txBody>
       </p:sp>
     </p:spTree>
-    <p:extLst>
-      <p:ext uri="{BB962C8B-B14F-4D97-AF65-F5344CB8AC3E}">
-        <p14:creationId xmlns:p14="http://schemas.microsoft.com/office/powerpoint/2010/main" val="1024086991"/>
-      </p:ext>
-    </p:extLst>
   </p:cSld>
   <p:clrMapOvr>
-    <a:masterClrMapping/>
+    <a:masterClrMapping xmlns:a="http://schemas.openxmlformats.org/drawingml/2006/main"/>
   </p:clrMapOvr>
 </p:notes>
 </file>
@@ -3133,7 +3116,7 @@
 </file>
 
 <file path=ppt/notesSlides/notesSlide37.xml><?xml version="1.0" encoding="utf-8"?>
-<p:notes xmlns:a="http://schemas.openxmlformats.org/drawingml/2006/main" xmlns:r="http://schemas.openxmlformats.org/officeDocument/2006/relationships" xmlns:p="http://schemas.openxmlformats.org/presentationml/2006/main">
+<p:notes xmlns:p="http://schemas.openxmlformats.org/presentationml/2006/main">
   <p:cSld>
     <p:spTree>
       <p:nvGrpSpPr>
@@ -3142,21 +3125,16 @@
         <p:nvPr/>
       </p:nvGrpSpPr>
       <p:grpSpPr>
-        <a:xfrm>
-          <a:off x="0" y="0"/>
-          <a:ext cx="0" cy="0"/>
-          <a:chOff x="0" y="0"/>
-          <a:chExt cx="0" cy="0"/>
-        </a:xfrm>
+        <a:xfrm xmlns:a="http://schemas.openxmlformats.org/drawingml/2006/main"/>
       </p:grpSpPr>
       <p:sp>
         <p:nvSpPr>
           <p:cNvPr id="2" name="Slide Image Placeholder 1"/>
           <p:cNvSpPr>
-            <a:spLocks noGrp="1" noRot="1" noChangeAspect="1"/>
+            <a:spLocks xmlns:a="http://schemas.openxmlformats.org/drawingml/2006/main" noGrp="1"/>
           </p:cNvSpPr>
           <p:nvPr>
-            <p:ph type="sldImg"/>
+            <p:ph type="sldImg" idx="0"/>
           </p:nvPr>
         </p:nvSpPr>
         <p:spPr/>
@@ -3165,7 +3143,7 @@
         <p:nvSpPr>
           <p:cNvPr id="3" name="Notes Placeholder 2"/>
           <p:cNvSpPr>
-            <a:spLocks noGrp="1"/>
+            <a:spLocks xmlns:a="http://schemas.openxmlformats.org/drawingml/2006/main" noGrp="1"/>
           </p:cNvSpPr>
           <p:nvPr>
             <p:ph type="body" idx="1"/>
@@ -3173,14 +3151,13 @@
         </p:nvSpPr>
         <p:spPr/>
         <p:txBody>
-          <a:bodyPr/>
-          <a:lstStyle/>
-          <a:p>
-            <a:r>
-              <a:rPr lang="en-US" dirty="0"/>
+          <a:bodyPr xmlns:a="http://schemas.openxmlformats.org/drawingml/2006/main"/>
+          <a:lstStyle xmlns:a="http://schemas.openxmlformats.org/drawingml/2006/main"/>
+          <a:p xmlns:a="http://schemas.openxmlformats.org/drawingml/2006/main">
+            <a:r>
               <a:t>За наредну вежбу сваки студент пише корисничку причу за једну ставку из домена свог пројекта, додаје успешне, негативне и граничне критеријуме прихватања, уводи ставку у ток на табли и ради преко feature гране, отвара Pull Request са доказом провере и спрема се да објасни цео пут од захтева до интегрисане промене. То је уједно припрема за прву контролну тачку.</a:t>
             </a:r>
-            <a:endParaRPr lang="en-US" dirty="0"/>
+            <a:endParaRPr/>
           </a:p>
         </p:txBody>
       </p:sp>
@@ -3188,34 +3165,23 @@
         <p:nvSpPr>
           <p:cNvPr id="4" name="Slide Number Placeholder 3"/>
           <p:cNvSpPr>
-            <a:spLocks noGrp="1"/>
+            <a:spLocks xmlns:a="http://schemas.openxmlformats.org/drawingml/2006/main" noGrp="1"/>
           </p:cNvSpPr>
           <p:nvPr>
-            <p:ph type="sldNum" sz="quarter" idx="10"/>
+            <p:ph type="sldNum" idx="5"/>
           </p:nvPr>
         </p:nvSpPr>
         <p:spPr/>
         <p:txBody>
-          <a:bodyPr/>
-          <a:lstStyle/>
-          <a:p>
-            <a:fld id="{F7021451-1387-4CA6-816F-3879F97B5CBC}" type="slidenum">
-              <a:rPr lang="en-US"/>
-              <a:t>37</a:t>
-            </a:fld>
-            <a:endParaRPr lang="en-US"/>
-          </a:p>
+          <a:bodyPr xmlns:a="http://schemas.openxmlformats.org/drawingml/2006/main"/>
+          <a:lstStyle xmlns:a="http://schemas.openxmlformats.org/drawingml/2006/main"/>
+          <a:p xmlns:a="http://schemas.openxmlformats.org/drawingml/2006/main"/>
         </p:txBody>
       </p:sp>
     </p:spTree>
-    <p:extLst>
-      <p:ext uri="{BB962C8B-B14F-4D97-AF65-F5344CB8AC3E}">
-        <p14:creationId xmlns:p14="http://schemas.microsoft.com/office/powerpoint/2010/main" val="1024086991"/>
-      </p:ext>
-    </p:extLst>
   </p:cSld>
   <p:clrMapOvr>
-    <a:masterClrMapping/>
+    <a:masterClrMapping xmlns:a="http://schemas.openxmlformats.org/drawingml/2006/main"/>
   </p:clrMapOvr>
 </p:notes>
 </file>
@@ -32682,11 +32648,11 @@
 </file>
 
 <file path=ppt/slides/slide32.xml><?xml version="1.0" encoding="utf-8"?>
-<p:sld xmlns:a="http://schemas.openxmlformats.org/drawingml/2006/main" xmlns:r="http://schemas.openxmlformats.org/officeDocument/2006/relationships" xmlns:p="http://schemas.openxmlformats.org/presentationml/2006/main">
-  <p:cSld name="Slide 32">
+<p:sld xmlns:p="http://schemas.openxmlformats.org/presentationml/2006/main">
+  <p:cSld>
     <p:bg>
       <p:bgPr>
-        <a:solidFill>
+        <a:solidFill xmlns:a="http://schemas.openxmlformats.org/drawingml/2006/main">
           <a:srgbClr val="F6F7F5"/>
         </a:solidFill>
       </p:bgPr>
@@ -32698,237 +32664,275 @@
         <p:nvPr/>
       </p:nvGrpSpPr>
       <p:grpSpPr>
-        <a:xfrm>
-          <a:off x="0" y="0"/>
-          <a:ext cx="0" cy="0"/>
-          <a:chOff x="0" y="0"/>
-          <a:chExt cx="0" cy="0"/>
-        </a:xfrm>
+        <a:xfrm xmlns:a="http://schemas.openxmlformats.org/drawingml/2006/main"/>
       </p:grpSpPr>
       <p:sp>
         <p:nvSpPr>
-          <p:cNvPr id="2" name="Shape 0"/>
-          <p:cNvSpPr/>
-          <p:nvPr/>
-        </p:nvSpPr>
-        <p:spPr>
-          <a:xfrm>
+          <p:cNvPr id="2" name="Shape 0">
+            <a:extLst xmlns:a="http://schemas.openxmlformats.org/drawingml/2006/main">
+              <a:ext uri="{FF2B5EF4-FFF2-40B4-BE49-F238E27FC236}">
+                <a16:creationId xmlns:a16="http://schemas.microsoft.com/office/drawing/2014/main" id="{4393458B-CA0A-4828-B933-25E1A8965F2A}"/>
+              </a:ext>
+            </a:extLst>
+          </p:cNvPr>
+          <p:cNvSpPr>
+            <a:spLocks xmlns:a="http://schemas.openxmlformats.org/drawingml/2006/main" noGrp="1"/>
+          </p:cNvSpPr>
+          <p:nvPr/>
+        </p:nvSpPr>
+        <p:spPr>
+          <a:xfrm xmlns:a="http://schemas.openxmlformats.org/drawingml/2006/main">
             <a:off x="812800" y="457200"/>
             <a:ext cx="457200" cy="38100"/>
           </a:xfrm>
-          <a:prstGeom prst="roundRect">
+          <a:prstGeom xmlns:a="http://schemas.openxmlformats.org/drawingml/2006/main" prst="roundRect">
             <a:avLst>
               <a:gd name="adj" fmla="val 50000"/>
             </a:avLst>
           </a:prstGeom>
-          <a:solidFill>
+          <a:solidFill xmlns:a="http://schemas.openxmlformats.org/drawingml/2006/main">
             <a:srgbClr val="0E6E68"/>
           </a:solidFill>
-          <a:ln/>
-        </p:spPr>
-      </p:sp>
-      <p:sp>
-        <p:nvSpPr>
-          <p:cNvPr id="3" name="Text 1"/>
-          <p:cNvSpPr/>
-          <p:nvPr/>
-        </p:nvSpPr>
-        <p:spPr>
-          <a:xfrm>
+        </p:spPr>
+      </p:sp>
+      <p:sp>
+        <p:nvSpPr>
+          <p:cNvPr id="3" name="Text 1">
+            <a:extLst xmlns:a="http://schemas.openxmlformats.org/drawingml/2006/main">
+              <a:ext uri="{FF2B5EF4-FFF2-40B4-BE49-F238E27FC236}">
+                <a16:creationId xmlns:a16="http://schemas.microsoft.com/office/drawing/2014/main" id="{5F274CDA-A1F3-4771-9544-012F9120F1F7}"/>
+              </a:ext>
+            </a:extLst>
+          </p:cNvPr>
+          <p:cNvSpPr>
+            <a:spLocks xmlns:a="http://schemas.openxmlformats.org/drawingml/2006/main" noGrp="1"/>
+          </p:cNvSpPr>
+          <p:nvPr/>
+        </p:nvSpPr>
+        <p:spPr>
+          <a:xfrm xmlns:a="http://schemas.openxmlformats.org/drawingml/2006/main">
             <a:off x="812800" y="711200"/>
             <a:ext cx="3904576" cy="238720"/>
           </a:xfrm>
-          <a:prstGeom prst="rect">
-            <a:avLst/>
-          </a:prstGeom>
-          <a:noFill/>
-          <a:ln/>
-        </p:spPr>
-        <p:txBody>
-          <a:bodyPr wrap="square" lIns="0" tIns="0" rIns="0" bIns="0" rtlCol="0" anchor="t">
-            <a:normAutofit/>
-          </a:bodyPr>
-          <a:lstStyle/>
-          <a:p>
-            <a:pPr algn="l" indent="0" marL="0">
+          <a:prstGeom xmlns:a="http://schemas.openxmlformats.org/drawingml/2006/main" prst="rect">
+            <a:avLst/>
+          </a:prstGeom>
+          <a:noFill xmlns:a="http://schemas.openxmlformats.org/drawingml/2006/main"/>
+        </p:spPr>
+        <p:txBody>
+          <a:bodyPr xmlns:a="http://schemas.openxmlformats.org/drawingml/2006/main" wrap="square" lIns="0" tIns="0" rIns="0" bIns="0" anchor="t">
+            <a:normAutofit/>
+          </a:bodyPr>
+          <a:lstStyle xmlns:a="http://schemas.openxmlformats.org/drawingml/2006/main"/>
+          <a:p xmlns:a="http://schemas.openxmlformats.org/drawingml/2006/main">
+            <a:pPr marL="0" indent="0" algn="l">
               <a:lnSpc>
                 <a:spcPts val="1680"/>
               </a:lnSpc>
               <a:buNone/>
             </a:pPr>
             <a:r>
-              <a:rPr lang="en-US" sz="1200" spc="100" kern="0" dirty="0">
+              <a:rPr sz="1200" spc="100">
                 <a:solidFill>
                   <a:srgbClr val="0E6E68"/>
                 </a:solidFill>
-                <a:latin typeface="IBM Plex Mono" pitchFamily="49" charset="0"/>
-                <a:ea typeface="IBM Plex Mono" pitchFamily="49" charset="-122"/>
-                <a:cs typeface="IBM Plex Mono" pitchFamily="49" charset="-120"/>
+                <a:latin typeface="IBM Plex Mono"/>
+                <a:ea typeface="IBM Plex Mono"/>
+                <a:cs typeface="IBM Plex Mono"/>
               </a:rPr>
               <a:t>05 · ПРЕДАЈА И КТ1</a:t>
             </a:r>
-            <a:endParaRPr lang="en-US" sz="1200" dirty="0"/>
-          </a:p>
-        </p:txBody>
-      </p:sp>
-      <p:sp>
-        <p:nvSpPr>
-          <p:cNvPr id="4" name="Text 2"/>
-          <p:cNvSpPr/>
+            <a:endParaRPr sz="1200"/>
+          </a:p>
+        </p:txBody>
+      </p:sp>
+      <p:sp>
+        <p:nvSpPr>
+          <p:cNvPr id="4" name="Text 2">
+            <a:extLst xmlns:a="http://schemas.openxmlformats.org/drawingml/2006/main">
+              <a:ext uri="{FF2B5EF4-FFF2-40B4-BE49-F238E27FC236}">
+                <a16:creationId xmlns:a16="http://schemas.microsoft.com/office/drawing/2014/main" id="{26288FD1-EFB8-45AD-840B-F46D553F2FFF}"/>
+              </a:ext>
+            </a:extLst>
+          </p:cNvPr>
+          <p:cNvSpPr>
+            <a:spLocks xmlns:a="http://schemas.openxmlformats.org/drawingml/2006/main" noGrp="1"/>
+          </p:cNvSpPr>
           <p:nvPr>
-            <p:ph type="title"/>
+            <p:ph type="title" idx="0"/>
           </p:nvPr>
         </p:nvSpPr>
         <p:spPr>
-          <a:xfrm>
+          <a:xfrm xmlns:a="http://schemas.openxmlformats.org/drawingml/2006/main">
             <a:off x="812800" y="1000720"/>
             <a:ext cx="4549021" cy="444500"/>
           </a:xfrm>
-          <a:prstGeom prst="rect">
-            <a:avLst/>
-          </a:prstGeom>
-          <a:noFill/>
-          <a:ln/>
-        </p:spPr>
-        <p:txBody>
-          <a:bodyPr wrap="square" lIns="0" tIns="0" rIns="0" bIns="0" rtlCol="0" anchor="t">
-            <a:normAutofit/>
-          </a:bodyPr>
-          <a:lstStyle/>
-          <a:p>
-            <a:pPr algn="l" indent="0" marL="0">
+          <a:prstGeom xmlns:a="http://schemas.openxmlformats.org/drawingml/2006/main" prst="rect">
+            <a:avLst/>
+          </a:prstGeom>
+          <a:noFill xmlns:a="http://schemas.openxmlformats.org/drawingml/2006/main"/>
+        </p:spPr>
+        <p:txBody>
+          <a:bodyPr xmlns:a="http://schemas.openxmlformats.org/drawingml/2006/main" wrap="square" lIns="0" tIns="0" rIns="0" bIns="0" anchor="t">
+            <a:normAutofit/>
+          </a:bodyPr>
+          <a:lstStyle xmlns:a="http://schemas.openxmlformats.org/drawingml/2006/main"/>
+          <a:p xmlns:a="http://schemas.openxmlformats.org/drawingml/2006/main">
+            <a:pPr marL="0" indent="0" algn="l">
               <a:lnSpc>
                 <a:spcPts val="3300"/>
               </a:lnSpc>
               <a:buNone/>
             </a:pPr>
             <a:r>
-              <a:rPr lang="en-US" sz="3000" b="1" i="0" spc="-50" kern="0" dirty="0">
+              <a:rPr sz="3000" b="1" i="0" spc="-50">
                 <a:solidFill>
                   <a:srgbClr val="13202D"/>
                 </a:solidFill>
-                <a:latin typeface="IBM Plex Sans" pitchFamily="34" charset="0"/>
-                <a:ea typeface="IBM Plex Sans" pitchFamily="34" charset="-122"/>
-                <a:cs typeface="IBM Plex Sans" pitchFamily="34" charset="-120"/>
+                <a:latin typeface="IBM Plex Sans"/>
+                <a:ea typeface="IBM Plex Sans"/>
+                <a:cs typeface="IBM Plex Sans"/>
               </a:rPr>
               <a:t>Контролна тачка КТ1</a:t>
             </a:r>
-            <a:endParaRPr lang="en-US" sz="3000" dirty="0"/>
-          </a:p>
-        </p:txBody>
-      </p:sp>
-      <p:sp>
-        <p:nvSpPr>
-          <p:cNvPr id="5" name="Text 3"/>
-          <p:cNvSpPr/>
-          <p:nvPr/>
-        </p:nvSpPr>
-        <p:spPr>
-          <a:xfrm>
+            <a:endParaRPr sz="3000"/>
+          </a:p>
+        </p:txBody>
+      </p:sp>
+      <p:sp>
+        <p:nvSpPr>
+          <p:cNvPr id="5" name="Text 3">
+            <a:extLst xmlns:a="http://schemas.openxmlformats.org/drawingml/2006/main">
+              <a:ext uri="{FF2B5EF4-FFF2-40B4-BE49-F238E27FC236}">
+                <a16:creationId xmlns:a16="http://schemas.microsoft.com/office/drawing/2014/main" id="{03BBE4E4-387A-405A-BEC5-FE9F215B7BA7}"/>
+              </a:ext>
+            </a:extLst>
+          </p:cNvPr>
+          <p:cNvSpPr>
+            <a:spLocks xmlns:a="http://schemas.openxmlformats.org/drawingml/2006/main" noGrp="1"/>
+          </p:cNvSpPr>
+          <p:nvPr/>
+        </p:nvSpPr>
+        <p:spPr>
+          <a:xfrm xmlns:a="http://schemas.openxmlformats.org/drawingml/2006/main">
             <a:off x="10352980" y="1069380"/>
             <a:ext cx="1026220" cy="350441"/>
           </a:xfrm>
-          <a:prstGeom prst="roundRect">
+          <a:prstGeom xmlns:a="http://schemas.openxmlformats.org/drawingml/2006/main" prst="roundRect">
             <a:avLst>
               <a:gd name="adj" fmla="val 50000"/>
             </a:avLst>
           </a:prstGeom>
-          <a:solidFill>
+          <a:solidFill xmlns:a="http://schemas.openxmlformats.org/drawingml/2006/main">
             <a:srgbClr val="DDEBEA"/>
           </a:solidFill>
-          <a:ln/>
-        </p:spPr>
-        <p:txBody>
-          <a:bodyPr wrap="none" lIns="0" tIns="0" rIns="0" bIns="0" rtlCol="0" anchor="ctr">
-            <a:normAutofit/>
-          </a:bodyPr>
-          <a:lstStyle/>
-          <a:p>
-            <a:pPr algn="ctr" indent="0" marL="0">
+        </p:spPr>
+        <p:txBody>
+          <a:bodyPr xmlns:a="http://schemas.openxmlformats.org/drawingml/2006/main" wrap="none" lIns="0" tIns="0" rIns="0" bIns="0" anchor="ctr">
+            <a:normAutofit fontScale="10000"/>
+          </a:bodyPr>
+          <a:lstStyle xmlns:a="http://schemas.openxmlformats.org/drawingml/2006/main"/>
+          <a:p xmlns:a="http://schemas.openxmlformats.org/drawingml/2006/main">
+            <a:pPr marL="0" indent="0" algn="ctr">
               <a:lnSpc>
                 <a:spcPts val="1960"/>
               </a:lnSpc>
               <a:buNone/>
             </a:pPr>
             <a:r>
-              <a:rPr lang="en-US" sz="1400" b="1" dirty="0">
+              <a:rPr sz="1400" b="1">
                 <a:solidFill>
                   <a:srgbClr val="0E6E68"/>
                 </a:solidFill>
-                <a:latin typeface="IBM Plex Mono" pitchFamily="49" charset="0"/>
-                <a:ea typeface="IBM Plex Mono" pitchFamily="49" charset="-122"/>
-                <a:cs typeface="IBM Plex Mono" pitchFamily="49" charset="-120"/>
-              </a:rPr>
-              <a:t>3 поена</a:t>
-            </a:r>
-            <a:endParaRPr lang="en-US" sz="1400" dirty="0"/>
-          </a:p>
-        </p:txBody>
-      </p:sp>
-      <p:sp>
-        <p:nvSpPr>
-          <p:cNvPr id="6" name="Text 4"/>
-          <p:cNvSpPr/>
-          <p:nvPr/>
-        </p:nvSpPr>
-        <p:spPr>
-          <a:xfrm>
+                <a:latin typeface="IBM Plex Mono"/>
+                <a:ea typeface="IBM Plex Mono"/>
+                <a:cs typeface="IBM Plex Mono"/>
+              </a:rPr>
+              <a:t>10 поена</a:t>
+            </a:r>
+            <a:endParaRPr sz="1400"/>
+          </a:p>
+        </p:txBody>
+      </p:sp>
+      <p:sp>
+        <p:nvSpPr>
+          <p:cNvPr id="6" name="Text 4">
+            <a:extLst xmlns:a="http://schemas.openxmlformats.org/drawingml/2006/main">
+              <a:ext uri="{FF2B5EF4-FFF2-40B4-BE49-F238E27FC236}">
+                <a16:creationId xmlns:a16="http://schemas.microsoft.com/office/drawing/2014/main" id="{CD9AC353-EADA-4735-BC5A-4C7D2232D01D}"/>
+              </a:ext>
+            </a:extLst>
+          </p:cNvPr>
+          <p:cNvSpPr>
+            <a:spLocks xmlns:a="http://schemas.openxmlformats.org/drawingml/2006/main" noGrp="1"/>
+          </p:cNvSpPr>
+          <p:nvPr/>
+        </p:nvSpPr>
+        <p:spPr>
+          <a:xfrm xmlns:a="http://schemas.openxmlformats.org/drawingml/2006/main">
             <a:off x="812800" y="1648420"/>
             <a:ext cx="10883392" cy="274241"/>
           </a:xfrm>
-          <a:prstGeom prst="rect">
-            <a:avLst/>
-          </a:prstGeom>
-          <a:noFill/>
-          <a:ln/>
-        </p:spPr>
-        <p:txBody>
-          <a:bodyPr wrap="square" lIns="0" tIns="0" rIns="0" bIns="0" rtlCol="0" anchor="t">
-            <a:normAutofit/>
-          </a:bodyPr>
-          <a:lstStyle/>
-          <a:p>
-            <a:pPr algn="l" indent="0" marL="0">
+          <a:prstGeom xmlns:a="http://schemas.openxmlformats.org/drawingml/2006/main" prst="rect">
+            <a:avLst/>
+          </a:prstGeom>
+          <a:noFill xmlns:a="http://schemas.openxmlformats.org/drawingml/2006/main"/>
+        </p:spPr>
+        <p:txBody>
+          <a:bodyPr xmlns:a="http://schemas.openxmlformats.org/drawingml/2006/main" wrap="square" lIns="0" tIns="0" rIns="0" bIns="0" anchor="t">
+            <a:normAutofit fontScale="100000"/>
+          </a:bodyPr>
+          <a:lstStyle xmlns:a="http://schemas.openxmlformats.org/drawingml/2006/main"/>
+          <a:p xmlns:a="http://schemas.openxmlformats.org/drawingml/2006/main">
+            <a:pPr marL="0" indent="0" algn="l">
               <a:lnSpc>
                 <a:spcPts val="1960"/>
               </a:lnSpc>
               <a:buNone/>
             </a:pPr>
             <a:r>
-              <a:rPr lang="en-US" sz="1400" dirty="0">
+              <a:rPr sz="1400">
                 <a:solidFill>
                   <a:srgbClr val="44505D"/>
                 </a:solidFill>
-                <a:latin typeface="IBM Plex Sans" pitchFamily="34" charset="0"/>
-                <a:ea typeface="IBM Plex Sans" pitchFamily="34" charset="-122"/>
-                <a:cs typeface="IBM Plex Sans" pitchFamily="34" charset="-120"/>
-              </a:rPr>
-              <a:t>После Вежбе 2, недеља од 19.10: проблем, backlog и развојни ток у репозиторијуму.</a:t>
-            </a:r>
-            <a:endParaRPr lang="en-US" sz="1400" dirty="0"/>
-          </a:p>
-        </p:txBody>
-      </p:sp>
-      <p:sp>
-        <p:nvSpPr>
-          <p:cNvPr id="7" name="Shape 5"/>
-          <p:cNvSpPr/>
-          <p:nvPr/>
-        </p:nvSpPr>
-        <p:spPr>
-          <a:xfrm>
+                <a:latin typeface="IBM Plex Sans"/>
+                <a:ea typeface="IBM Plex Sans"/>
+                <a:cs typeface="IBM Plex Sans"/>
+              </a:rPr>
+              <a:t>КТ1 у термину Вежбе 4: основна имплементација, извршив ток и тест.</a:t>
+            </a:r>
+            <a:endParaRPr sz="1400"/>
+          </a:p>
+        </p:txBody>
+      </p:sp>
+      <p:sp>
+        <p:nvSpPr>
+          <p:cNvPr id="7" name="Shape 5">
+            <a:extLst xmlns:a="http://schemas.openxmlformats.org/drawingml/2006/main">
+              <a:ext uri="{FF2B5EF4-FFF2-40B4-BE49-F238E27FC236}">
+                <a16:creationId xmlns:a16="http://schemas.microsoft.com/office/drawing/2014/main" id="{D1DAC49E-FE35-4A2A-855F-33EBB289C9AC}"/>
+              </a:ext>
+            </a:extLst>
+          </p:cNvPr>
+          <p:cNvSpPr>
+            <a:spLocks xmlns:a="http://schemas.openxmlformats.org/drawingml/2006/main" noGrp="1"/>
+          </p:cNvSpPr>
+          <p:nvPr/>
+        </p:nvSpPr>
+        <p:spPr>
+          <a:xfrm xmlns:a="http://schemas.openxmlformats.org/drawingml/2006/main">
             <a:off x="815975" y="2129036"/>
             <a:ext cx="5213350" cy="801291"/>
           </a:xfrm>
-          <a:prstGeom prst="roundRect">
+          <a:prstGeom xmlns:a="http://schemas.openxmlformats.org/drawingml/2006/main" prst="roundRect">
             <a:avLst>
               <a:gd name="adj" fmla="val 12283"/>
             </a:avLst>
           </a:prstGeom>
-          <a:solidFill>
+          <a:solidFill xmlns:a="http://schemas.openxmlformats.org/drawingml/2006/main">
             <a:srgbClr val="FCFCFB"/>
           </a:solidFill>
-          <a:ln w="6350">
+          <a:ln xmlns:a="http://schemas.openxmlformats.org/drawingml/2006/main" w="6350">
             <a:solidFill>
               <a:srgbClr val="D3DAE1"/>
             </a:solidFill>
@@ -32938,156 +32942,185 @@
       </p:sp>
       <p:sp>
         <p:nvSpPr>
-          <p:cNvPr id="8" name="Text 6"/>
-          <p:cNvSpPr/>
-          <p:nvPr/>
-        </p:nvSpPr>
-        <p:spPr>
-          <a:xfrm>
+          <p:cNvPr id="8" name="Text 6">
+            <a:extLst xmlns:a="http://schemas.openxmlformats.org/drawingml/2006/main">
+              <a:ext uri="{FF2B5EF4-FFF2-40B4-BE49-F238E27FC236}">
+                <a16:creationId xmlns:a16="http://schemas.microsoft.com/office/drawing/2014/main" id="{12E085EA-1381-409B-A132-76AC14F11214}"/>
+              </a:ext>
+            </a:extLst>
+          </p:cNvPr>
+          <p:cNvSpPr>
+            <a:spLocks xmlns:a="http://schemas.openxmlformats.org/drawingml/2006/main" noGrp="1"/>
+          </p:cNvSpPr>
+          <p:nvPr/>
+        </p:nvSpPr>
+        <p:spPr>
+          <a:xfrm xmlns:a="http://schemas.openxmlformats.org/drawingml/2006/main">
             <a:off x="1022350" y="2297311"/>
             <a:ext cx="402431" cy="332680"/>
           </a:xfrm>
-          <a:prstGeom prst="rect">
-            <a:avLst/>
-          </a:prstGeom>
-          <a:noFill/>
-          <a:ln/>
-        </p:spPr>
-        <p:txBody>
-          <a:bodyPr wrap="square" lIns="0" tIns="0" rIns="0" bIns="0" rtlCol="0" anchor="t">
-            <a:normAutofit/>
-          </a:bodyPr>
-          <a:lstStyle/>
-          <a:p>
-            <a:pPr algn="l" indent="0" marL="0">
+          <a:prstGeom xmlns:a="http://schemas.openxmlformats.org/drawingml/2006/main" prst="rect">
+            <a:avLst/>
+          </a:prstGeom>
+          <a:noFill xmlns:a="http://schemas.openxmlformats.org/drawingml/2006/main"/>
+        </p:spPr>
+        <p:txBody>
+          <a:bodyPr xmlns:a="http://schemas.openxmlformats.org/drawingml/2006/main" wrap="square" lIns="0" tIns="0" rIns="0" bIns="0" anchor="t">
+            <a:normAutofit/>
+          </a:bodyPr>
+          <a:lstStyle xmlns:a="http://schemas.openxmlformats.org/drawingml/2006/main"/>
+          <a:p xmlns:a="http://schemas.openxmlformats.org/drawingml/2006/main">
+            <a:pPr marL="0" indent="0" algn="l">
               <a:lnSpc>
                 <a:spcPts val="2420"/>
               </a:lnSpc>
               <a:buNone/>
             </a:pPr>
             <a:r>
-              <a:rPr lang="en-US" sz="2200" dirty="0">
+              <a:rPr sz="2200">
                 <a:solidFill>
                   <a:srgbClr val="0E6E68"/>
                 </a:solidFill>
-                <a:latin typeface="IBM Plex Mono" pitchFamily="49" charset="0"/>
-                <a:ea typeface="IBM Plex Mono" pitchFamily="49" charset="-122"/>
-                <a:cs typeface="IBM Plex Mono" pitchFamily="49" charset="-120"/>
+                <a:latin typeface="IBM Plex Mono"/>
+                <a:ea typeface="IBM Plex Mono"/>
+                <a:cs typeface="IBM Plex Mono"/>
               </a:rPr>
               <a:t>01</a:t>
             </a:r>
-            <a:endParaRPr lang="en-US" sz="2200" dirty="0"/>
-          </a:p>
-        </p:txBody>
-      </p:sp>
-      <p:sp>
-        <p:nvSpPr>
-          <p:cNvPr id="9" name="Text 7"/>
-          <p:cNvSpPr/>
-          <p:nvPr/>
-        </p:nvSpPr>
-        <p:spPr>
-          <a:xfrm>
+            <a:endParaRPr sz="2200"/>
+          </a:p>
+        </p:txBody>
+      </p:sp>
+      <p:sp>
+        <p:nvSpPr>
+          <p:cNvPr id="9" name="Text 7">
+            <a:extLst xmlns:a="http://schemas.openxmlformats.org/drawingml/2006/main">
+              <a:ext uri="{FF2B5EF4-FFF2-40B4-BE49-F238E27FC236}">
+                <a16:creationId xmlns:a16="http://schemas.microsoft.com/office/drawing/2014/main" id="{AFFE1F34-DF6B-4E22-AC2A-3864F6B64784}"/>
+              </a:ext>
+            </a:extLst>
+          </p:cNvPr>
+          <p:cNvSpPr>
+            <a:spLocks xmlns:a="http://schemas.openxmlformats.org/drawingml/2006/main" noGrp="1"/>
+          </p:cNvSpPr>
+          <p:nvPr/>
+        </p:nvSpPr>
+        <p:spPr>
+          <a:xfrm xmlns:a="http://schemas.openxmlformats.org/drawingml/2006/main">
             <a:off x="1510109" y="2297311"/>
             <a:ext cx="4442226" cy="238720"/>
           </a:xfrm>
-          <a:prstGeom prst="rect">
-            <a:avLst/>
-          </a:prstGeom>
-          <a:noFill/>
-          <a:ln/>
-        </p:spPr>
-        <p:txBody>
-          <a:bodyPr wrap="square" lIns="0" tIns="0" rIns="0" bIns="0" rtlCol="0" anchor="t">
-            <a:normAutofit/>
-          </a:bodyPr>
-          <a:lstStyle/>
-          <a:p>
-            <a:pPr algn="l" indent="0" marL="0">
+          <a:prstGeom xmlns:a="http://schemas.openxmlformats.org/drawingml/2006/main" prst="rect">
+            <a:avLst/>
+          </a:prstGeom>
+          <a:noFill xmlns:a="http://schemas.openxmlformats.org/drawingml/2006/main"/>
+        </p:spPr>
+        <p:txBody>
+          <a:bodyPr xmlns:a="http://schemas.openxmlformats.org/drawingml/2006/main" wrap="square" lIns="0" tIns="0" rIns="0" bIns="0" anchor="t">
+            <a:normAutofit/>
+          </a:bodyPr>
+          <a:lstStyle xmlns:a="http://schemas.openxmlformats.org/drawingml/2006/main"/>
+          <a:p xmlns:a="http://schemas.openxmlformats.org/drawingml/2006/main">
+            <a:pPr marL="0" indent="0" algn="l">
               <a:lnSpc>
                 <a:spcPts val="1680"/>
               </a:lnSpc>
               <a:buNone/>
             </a:pPr>
             <a:r>
-              <a:rPr lang="en-US" sz="1400" b="1" dirty="0">
+              <a:rPr sz="1400" b="1">
                 <a:solidFill>
                   <a:srgbClr val="13202D"/>
                 </a:solidFill>
-                <a:latin typeface="IBM Plex Sans" pitchFamily="34" charset="0"/>
-                <a:ea typeface="IBM Plex Sans" pitchFamily="34" charset="-122"/>
-                <a:cs typeface="IBM Plex Sans" pitchFamily="34" charset="-120"/>
+                <a:latin typeface="IBM Plex Sans"/>
+                <a:ea typeface="IBM Plex Sans"/>
+                <a:cs typeface="IBM Plex Sans"/>
               </a:rPr>
               <a:t>Репозиторијум и README</a:t>
             </a:r>
-            <a:endParaRPr lang="en-US" sz="1400" dirty="0"/>
-          </a:p>
-        </p:txBody>
-      </p:sp>
-      <p:sp>
-        <p:nvSpPr>
-          <p:cNvPr id="10" name="Text 8"/>
-          <p:cNvSpPr/>
-          <p:nvPr/>
-        </p:nvSpPr>
-        <p:spPr>
-          <a:xfrm>
+            <a:endParaRPr sz="1400"/>
+          </a:p>
+        </p:txBody>
+      </p:sp>
+      <p:sp>
+        <p:nvSpPr>
+          <p:cNvPr id="10" name="Text 8">
+            <a:extLst xmlns:a="http://schemas.openxmlformats.org/drawingml/2006/main">
+              <a:ext uri="{FF2B5EF4-FFF2-40B4-BE49-F238E27FC236}">
+                <a16:creationId xmlns:a16="http://schemas.microsoft.com/office/drawing/2014/main" id="{566DAF11-295F-4F95-A9F5-C0FE01CED65F}"/>
+              </a:ext>
+            </a:extLst>
+          </p:cNvPr>
+          <p:cNvSpPr>
+            <a:spLocks xmlns:a="http://schemas.openxmlformats.org/drawingml/2006/main" noGrp="1"/>
+          </p:cNvSpPr>
+          <p:nvPr/>
+        </p:nvSpPr>
+        <p:spPr>
+          <a:xfrm xmlns:a="http://schemas.openxmlformats.org/drawingml/2006/main">
             <a:off x="1510109" y="2548731"/>
             <a:ext cx="4442226" cy="238720"/>
           </a:xfrm>
-          <a:prstGeom prst="rect">
-            <a:avLst/>
-          </a:prstGeom>
-          <a:noFill/>
-          <a:ln/>
-        </p:spPr>
-        <p:txBody>
-          <a:bodyPr wrap="square" lIns="0" tIns="0" rIns="0" bIns="0" rtlCol="0" anchor="t">
-            <a:normAutofit/>
-          </a:bodyPr>
-          <a:lstStyle/>
-          <a:p>
-            <a:pPr algn="l" indent="0" marL="0">
+          <a:prstGeom xmlns:a="http://schemas.openxmlformats.org/drawingml/2006/main" prst="rect">
+            <a:avLst/>
+          </a:prstGeom>
+          <a:noFill xmlns:a="http://schemas.openxmlformats.org/drawingml/2006/main"/>
+        </p:spPr>
+        <p:txBody>
+          <a:bodyPr xmlns:a="http://schemas.openxmlformats.org/drawingml/2006/main" wrap="square" lIns="0" tIns="0" rIns="0" bIns="0" anchor="t">
+            <a:normAutofit/>
+          </a:bodyPr>
+          <a:lstStyle xmlns:a="http://schemas.openxmlformats.org/drawingml/2006/main"/>
+          <a:p xmlns:a="http://schemas.openxmlformats.org/drawingml/2006/main">
+            <a:pPr marL="0" indent="0" algn="l">
               <a:lnSpc>
                 <a:spcPts val="1680"/>
               </a:lnSpc>
               <a:buNone/>
             </a:pPr>
             <a:r>
-              <a:rPr lang="en-US" sz="1200" dirty="0">
+              <a:rPr sz="1200">
                 <a:solidFill>
                   <a:srgbClr val="44505D"/>
                 </a:solidFill>
-                <a:latin typeface="IBM Plex Sans" pitchFamily="34" charset="0"/>
-                <a:ea typeface="IBM Plex Sans" pitchFamily="34" charset="-122"/>
-                <a:cs typeface="IBM Plex Sans" pitchFamily="34" charset="-120"/>
+                <a:latin typeface="IBM Plex Sans"/>
+                <a:ea typeface="IBM Plex Sans"/>
+                <a:cs typeface="IBM Plex Sans"/>
               </a:rPr>
               <a:t>README и приступ свих чланова тима</a:t>
             </a:r>
-            <a:endParaRPr lang="en-US" sz="1200" dirty="0"/>
-          </a:p>
-        </p:txBody>
-      </p:sp>
-      <p:sp>
-        <p:nvSpPr>
-          <p:cNvPr id="11" name="Shape 9"/>
-          <p:cNvSpPr/>
-          <p:nvPr/>
-        </p:nvSpPr>
-        <p:spPr>
-          <a:xfrm>
+            <a:endParaRPr sz="1200"/>
+          </a:p>
+        </p:txBody>
+      </p:sp>
+      <p:sp>
+        <p:nvSpPr>
+          <p:cNvPr id="11" name="Shape 9">
+            <a:extLst xmlns:a="http://schemas.openxmlformats.org/drawingml/2006/main">
+              <a:ext uri="{FF2B5EF4-FFF2-40B4-BE49-F238E27FC236}">
+                <a16:creationId xmlns:a16="http://schemas.microsoft.com/office/drawing/2014/main" id="{642747D0-A150-4F69-A2DE-E392A0D05FF3}"/>
+              </a:ext>
+            </a:extLst>
+          </p:cNvPr>
+          <p:cNvSpPr>
+            <a:spLocks xmlns:a="http://schemas.openxmlformats.org/drawingml/2006/main" noGrp="1"/>
+          </p:cNvSpPr>
+          <p:nvPr/>
+        </p:nvSpPr>
+        <p:spPr>
+          <a:xfrm xmlns:a="http://schemas.openxmlformats.org/drawingml/2006/main">
             <a:off x="6162675" y="2129036"/>
             <a:ext cx="5213350" cy="801291"/>
           </a:xfrm>
-          <a:prstGeom prst="roundRect">
+          <a:prstGeom xmlns:a="http://schemas.openxmlformats.org/drawingml/2006/main" prst="roundRect">
             <a:avLst>
               <a:gd name="adj" fmla="val 12283"/>
             </a:avLst>
           </a:prstGeom>
-          <a:solidFill>
+          <a:solidFill xmlns:a="http://schemas.openxmlformats.org/drawingml/2006/main">
             <a:srgbClr val="FCFCFB"/>
           </a:solidFill>
-          <a:ln w="6350">
+          <a:ln xmlns:a="http://schemas.openxmlformats.org/drawingml/2006/main" w="6350">
             <a:solidFill>
               <a:srgbClr val="D3DAE1"/>
             </a:solidFill>
@@ -33097,156 +33130,185 @@
       </p:sp>
       <p:sp>
         <p:nvSpPr>
-          <p:cNvPr id="12" name="Text 10"/>
-          <p:cNvSpPr/>
-          <p:nvPr/>
-        </p:nvSpPr>
-        <p:spPr>
-          <a:xfrm>
+          <p:cNvPr id="12" name="Text 10">
+            <a:extLst xmlns:a="http://schemas.openxmlformats.org/drawingml/2006/main">
+              <a:ext uri="{FF2B5EF4-FFF2-40B4-BE49-F238E27FC236}">
+                <a16:creationId xmlns:a16="http://schemas.microsoft.com/office/drawing/2014/main" id="{9EA332C3-CFA9-4A0F-B8AD-461BFDC90353}"/>
+              </a:ext>
+            </a:extLst>
+          </p:cNvPr>
+          <p:cNvSpPr>
+            <a:spLocks xmlns:a="http://schemas.openxmlformats.org/drawingml/2006/main" noGrp="1"/>
+          </p:cNvSpPr>
+          <p:nvPr/>
+        </p:nvSpPr>
+        <p:spPr>
+          <a:xfrm xmlns:a="http://schemas.openxmlformats.org/drawingml/2006/main">
             <a:off x="6369050" y="2297311"/>
             <a:ext cx="402431" cy="332680"/>
           </a:xfrm>
-          <a:prstGeom prst="rect">
-            <a:avLst/>
-          </a:prstGeom>
-          <a:noFill/>
-          <a:ln/>
-        </p:spPr>
-        <p:txBody>
-          <a:bodyPr wrap="square" lIns="0" tIns="0" rIns="0" bIns="0" rtlCol="0" anchor="t">
-            <a:normAutofit/>
-          </a:bodyPr>
-          <a:lstStyle/>
-          <a:p>
-            <a:pPr algn="l" indent="0" marL="0">
+          <a:prstGeom xmlns:a="http://schemas.openxmlformats.org/drawingml/2006/main" prst="rect">
+            <a:avLst/>
+          </a:prstGeom>
+          <a:noFill xmlns:a="http://schemas.openxmlformats.org/drawingml/2006/main"/>
+        </p:spPr>
+        <p:txBody>
+          <a:bodyPr xmlns:a="http://schemas.openxmlformats.org/drawingml/2006/main" wrap="square" lIns="0" tIns="0" rIns="0" bIns="0" anchor="t">
+            <a:normAutofit/>
+          </a:bodyPr>
+          <a:lstStyle xmlns:a="http://schemas.openxmlformats.org/drawingml/2006/main"/>
+          <a:p xmlns:a="http://schemas.openxmlformats.org/drawingml/2006/main">
+            <a:pPr marL="0" indent="0" algn="l">
               <a:lnSpc>
                 <a:spcPts val="2420"/>
               </a:lnSpc>
               <a:buNone/>
             </a:pPr>
             <a:r>
-              <a:rPr lang="en-US" sz="2200" dirty="0">
+              <a:rPr sz="2200">
                 <a:solidFill>
                   <a:srgbClr val="0E6E68"/>
                 </a:solidFill>
-                <a:latin typeface="IBM Plex Mono" pitchFamily="49" charset="0"/>
-                <a:ea typeface="IBM Plex Mono" pitchFamily="49" charset="-122"/>
-                <a:cs typeface="IBM Plex Mono" pitchFamily="49" charset="-120"/>
+                <a:latin typeface="IBM Plex Mono"/>
+                <a:ea typeface="IBM Plex Mono"/>
+                <a:cs typeface="IBM Plex Mono"/>
               </a:rPr>
               <a:t>02</a:t>
             </a:r>
-            <a:endParaRPr lang="en-US" sz="2200" dirty="0"/>
-          </a:p>
-        </p:txBody>
-      </p:sp>
-      <p:sp>
-        <p:nvSpPr>
-          <p:cNvPr id="13" name="Text 11"/>
-          <p:cNvSpPr/>
-          <p:nvPr/>
-        </p:nvSpPr>
-        <p:spPr>
-          <a:xfrm>
+            <a:endParaRPr sz="2200"/>
+          </a:p>
+        </p:txBody>
+      </p:sp>
+      <p:sp>
+        <p:nvSpPr>
+          <p:cNvPr id="13" name="Text 11">
+            <a:extLst xmlns:a="http://schemas.openxmlformats.org/drawingml/2006/main">
+              <a:ext uri="{FF2B5EF4-FFF2-40B4-BE49-F238E27FC236}">
+                <a16:creationId xmlns:a16="http://schemas.microsoft.com/office/drawing/2014/main" id="{F2AD29ED-2AE4-4EA2-81D0-B62212328E12}"/>
+              </a:ext>
+            </a:extLst>
+          </p:cNvPr>
+          <p:cNvSpPr>
+            <a:spLocks xmlns:a="http://schemas.openxmlformats.org/drawingml/2006/main" noGrp="1"/>
+          </p:cNvSpPr>
+          <p:nvPr/>
+        </p:nvSpPr>
+        <p:spPr>
+          <a:xfrm xmlns:a="http://schemas.openxmlformats.org/drawingml/2006/main">
             <a:off x="6856809" y="2297311"/>
             <a:ext cx="4442226" cy="238720"/>
           </a:xfrm>
-          <a:prstGeom prst="rect">
-            <a:avLst/>
-          </a:prstGeom>
-          <a:noFill/>
-          <a:ln/>
-        </p:spPr>
-        <p:txBody>
-          <a:bodyPr wrap="square" lIns="0" tIns="0" rIns="0" bIns="0" rtlCol="0" anchor="t">
-            <a:normAutofit/>
-          </a:bodyPr>
-          <a:lstStyle/>
-          <a:p>
-            <a:pPr algn="l" indent="0" marL="0">
+          <a:prstGeom xmlns:a="http://schemas.openxmlformats.org/drawingml/2006/main" prst="rect">
+            <a:avLst/>
+          </a:prstGeom>
+          <a:noFill xmlns:a="http://schemas.openxmlformats.org/drawingml/2006/main"/>
+        </p:spPr>
+        <p:txBody>
+          <a:bodyPr xmlns:a="http://schemas.openxmlformats.org/drawingml/2006/main" wrap="square" lIns="0" tIns="0" rIns="0" bIns="0" anchor="t">
+            <a:normAutofit/>
+          </a:bodyPr>
+          <a:lstStyle xmlns:a="http://schemas.openxmlformats.org/drawingml/2006/main"/>
+          <a:p xmlns:a="http://schemas.openxmlformats.org/drawingml/2006/main">
+            <a:pPr marL="0" indent="0" algn="l">
               <a:lnSpc>
                 <a:spcPts val="1680"/>
               </a:lnSpc>
               <a:buNone/>
             </a:pPr>
             <a:r>
-              <a:rPr lang="en-US" sz="1400" b="1" dirty="0">
+              <a:rPr sz="1400" b="1">
                 <a:solidFill>
                   <a:srgbClr val="13202D"/>
                 </a:solidFill>
-                <a:latin typeface="IBM Plex Sans" pitchFamily="34" charset="0"/>
-                <a:ea typeface="IBM Plex Sans" pitchFamily="34" charset="-122"/>
-                <a:cs typeface="IBM Plex Sans" pitchFamily="34" charset="-120"/>
+                <a:latin typeface="IBM Plex Sans"/>
+                <a:ea typeface="IBM Plex Sans"/>
+                <a:cs typeface="IBM Plex Sans"/>
               </a:rPr>
               <a:t>Backlog у Tapiz Boards</a:t>
             </a:r>
-            <a:endParaRPr lang="en-US" sz="1400" dirty="0"/>
-          </a:p>
-        </p:txBody>
-      </p:sp>
-      <p:sp>
-        <p:nvSpPr>
-          <p:cNvPr id="14" name="Text 12"/>
-          <p:cNvSpPr/>
-          <p:nvPr/>
-        </p:nvSpPr>
-        <p:spPr>
-          <a:xfrm>
+            <a:endParaRPr sz="1400"/>
+          </a:p>
+        </p:txBody>
+      </p:sp>
+      <p:sp>
+        <p:nvSpPr>
+          <p:cNvPr id="14" name="Text 12">
+            <a:extLst xmlns:a="http://schemas.openxmlformats.org/drawingml/2006/main">
+              <a:ext uri="{FF2B5EF4-FFF2-40B4-BE49-F238E27FC236}">
+                <a16:creationId xmlns:a16="http://schemas.microsoft.com/office/drawing/2014/main" id="{6522A8B3-6A88-4BAD-B47B-2954079F0A00}"/>
+              </a:ext>
+            </a:extLst>
+          </p:cNvPr>
+          <p:cNvSpPr>
+            <a:spLocks xmlns:a="http://schemas.openxmlformats.org/drawingml/2006/main" noGrp="1"/>
+          </p:cNvSpPr>
+          <p:nvPr/>
+        </p:nvSpPr>
+        <p:spPr>
+          <a:xfrm xmlns:a="http://schemas.openxmlformats.org/drawingml/2006/main">
             <a:off x="6856809" y="2548731"/>
             <a:ext cx="4442226" cy="238720"/>
           </a:xfrm>
-          <a:prstGeom prst="rect">
-            <a:avLst/>
-          </a:prstGeom>
-          <a:noFill/>
-          <a:ln/>
-        </p:spPr>
-        <p:txBody>
-          <a:bodyPr wrap="square" lIns="0" tIns="0" rIns="0" bIns="0" rtlCol="0" anchor="t">
-            <a:normAutofit/>
-          </a:bodyPr>
-          <a:lstStyle/>
-          <a:p>
-            <a:pPr algn="l" indent="0" marL="0">
+          <a:prstGeom xmlns:a="http://schemas.openxmlformats.org/drawingml/2006/main" prst="rect">
+            <a:avLst/>
+          </a:prstGeom>
+          <a:noFill xmlns:a="http://schemas.openxmlformats.org/drawingml/2006/main"/>
+        </p:spPr>
+        <p:txBody>
+          <a:bodyPr xmlns:a="http://schemas.openxmlformats.org/drawingml/2006/main" wrap="square" lIns="0" tIns="0" rIns="0" bIns="0" anchor="t">
+            <a:normAutofit/>
+          </a:bodyPr>
+          <a:lstStyle xmlns:a="http://schemas.openxmlformats.org/drawingml/2006/main"/>
+          <a:p xmlns:a="http://schemas.openxmlformats.org/drawingml/2006/main">
+            <a:pPr marL="0" indent="0" algn="l">
               <a:lnSpc>
                 <a:spcPts val="1680"/>
               </a:lnSpc>
               <a:buNone/>
             </a:pPr>
             <a:r>
-              <a:rPr lang="en-US" sz="1200" dirty="0">
+              <a:rPr sz="1200">
                 <a:solidFill>
                   <a:srgbClr val="44505D"/>
                 </a:solidFill>
-                <a:latin typeface="IBM Plex Sans" pitchFamily="34" charset="0"/>
-                <a:ea typeface="IBM Plex Sans" pitchFamily="34" charset="-122"/>
-                <a:cs typeface="IBM Plex Sans" pitchFamily="34" charset="-120"/>
+                <a:latin typeface="IBM Plex Sans"/>
+                <a:ea typeface="IBM Plex Sans"/>
+                <a:cs typeface="IBM Plex Sans"/>
               </a:rPr>
               <a:t>приоритети и критеријуми прихватања</a:t>
             </a:r>
-            <a:endParaRPr lang="en-US" sz="1200" dirty="0"/>
-          </a:p>
-        </p:txBody>
-      </p:sp>
-      <p:sp>
-        <p:nvSpPr>
-          <p:cNvPr id="15" name="Shape 13"/>
-          <p:cNvSpPr/>
-          <p:nvPr/>
-        </p:nvSpPr>
-        <p:spPr>
-          <a:xfrm>
+            <a:endParaRPr sz="1200"/>
+          </a:p>
+        </p:txBody>
+      </p:sp>
+      <p:sp>
+        <p:nvSpPr>
+          <p:cNvPr id="15" name="Shape 13">
+            <a:extLst xmlns:a="http://schemas.openxmlformats.org/drawingml/2006/main">
+              <a:ext uri="{FF2B5EF4-FFF2-40B4-BE49-F238E27FC236}">
+                <a16:creationId xmlns:a16="http://schemas.microsoft.com/office/drawing/2014/main" id="{27EECE1A-AD3F-41BD-8E90-73173E6EBC54}"/>
+              </a:ext>
+            </a:extLst>
+          </p:cNvPr>
+          <p:cNvSpPr>
+            <a:spLocks xmlns:a="http://schemas.openxmlformats.org/drawingml/2006/main" noGrp="1"/>
+          </p:cNvSpPr>
+          <p:nvPr/>
+        </p:nvSpPr>
+        <p:spPr>
+          <a:xfrm xmlns:a="http://schemas.openxmlformats.org/drawingml/2006/main">
             <a:off x="815975" y="3063677"/>
             <a:ext cx="5213350" cy="801291"/>
           </a:xfrm>
-          <a:prstGeom prst="roundRect">
+          <a:prstGeom xmlns:a="http://schemas.openxmlformats.org/drawingml/2006/main" prst="roundRect">
             <a:avLst>
               <a:gd name="adj" fmla="val 12283"/>
             </a:avLst>
           </a:prstGeom>
-          <a:solidFill>
+          <a:solidFill xmlns:a="http://schemas.openxmlformats.org/drawingml/2006/main">
             <a:srgbClr val="FCFCFB"/>
           </a:solidFill>
-          <a:ln w="6350">
+          <a:ln xmlns:a="http://schemas.openxmlformats.org/drawingml/2006/main" w="6350">
             <a:solidFill>
               <a:srgbClr val="D3DAE1"/>
             </a:solidFill>
@@ -33256,156 +33318,185 @@
       </p:sp>
       <p:sp>
         <p:nvSpPr>
-          <p:cNvPr id="16" name="Text 14"/>
-          <p:cNvSpPr/>
-          <p:nvPr/>
-        </p:nvSpPr>
-        <p:spPr>
-          <a:xfrm>
+          <p:cNvPr id="16" name="Text 14">
+            <a:extLst xmlns:a="http://schemas.openxmlformats.org/drawingml/2006/main">
+              <a:ext uri="{FF2B5EF4-FFF2-40B4-BE49-F238E27FC236}">
+                <a16:creationId xmlns:a16="http://schemas.microsoft.com/office/drawing/2014/main" id="{1778732D-CB4A-4D80-9C9A-3D937719833A}"/>
+              </a:ext>
+            </a:extLst>
+          </p:cNvPr>
+          <p:cNvSpPr>
+            <a:spLocks xmlns:a="http://schemas.openxmlformats.org/drawingml/2006/main" noGrp="1"/>
+          </p:cNvSpPr>
+          <p:nvPr/>
+        </p:nvSpPr>
+        <p:spPr>
+          <a:xfrm xmlns:a="http://schemas.openxmlformats.org/drawingml/2006/main">
             <a:off x="1022350" y="3231952"/>
             <a:ext cx="402431" cy="332680"/>
           </a:xfrm>
-          <a:prstGeom prst="rect">
-            <a:avLst/>
-          </a:prstGeom>
-          <a:noFill/>
-          <a:ln/>
-        </p:spPr>
-        <p:txBody>
-          <a:bodyPr wrap="square" lIns="0" tIns="0" rIns="0" bIns="0" rtlCol="0" anchor="t">
-            <a:normAutofit/>
-          </a:bodyPr>
-          <a:lstStyle/>
-          <a:p>
-            <a:pPr algn="l" indent="0" marL="0">
+          <a:prstGeom xmlns:a="http://schemas.openxmlformats.org/drawingml/2006/main" prst="rect">
+            <a:avLst/>
+          </a:prstGeom>
+          <a:noFill xmlns:a="http://schemas.openxmlformats.org/drawingml/2006/main"/>
+        </p:spPr>
+        <p:txBody>
+          <a:bodyPr xmlns:a="http://schemas.openxmlformats.org/drawingml/2006/main" wrap="square" lIns="0" tIns="0" rIns="0" bIns="0" anchor="t">
+            <a:normAutofit/>
+          </a:bodyPr>
+          <a:lstStyle xmlns:a="http://schemas.openxmlformats.org/drawingml/2006/main"/>
+          <a:p xmlns:a="http://schemas.openxmlformats.org/drawingml/2006/main">
+            <a:pPr marL="0" indent="0" algn="l">
               <a:lnSpc>
                 <a:spcPts val="2420"/>
               </a:lnSpc>
               <a:buNone/>
             </a:pPr>
             <a:r>
-              <a:rPr lang="en-US" sz="2200" dirty="0">
+              <a:rPr sz="2200">
                 <a:solidFill>
                   <a:srgbClr val="0E6E68"/>
                 </a:solidFill>
-                <a:latin typeface="IBM Plex Mono" pitchFamily="49" charset="0"/>
-                <a:ea typeface="IBM Plex Mono" pitchFamily="49" charset="-122"/>
-                <a:cs typeface="IBM Plex Mono" pitchFamily="49" charset="-120"/>
+                <a:latin typeface="IBM Plex Mono"/>
+                <a:ea typeface="IBM Plex Mono"/>
+                <a:cs typeface="IBM Plex Mono"/>
               </a:rPr>
               <a:t>03</a:t>
             </a:r>
-            <a:endParaRPr lang="en-US" sz="2200" dirty="0"/>
-          </a:p>
-        </p:txBody>
-      </p:sp>
-      <p:sp>
-        <p:nvSpPr>
-          <p:cNvPr id="17" name="Text 15"/>
-          <p:cNvSpPr/>
-          <p:nvPr/>
-        </p:nvSpPr>
-        <p:spPr>
-          <a:xfrm>
+            <a:endParaRPr sz="2200"/>
+          </a:p>
+        </p:txBody>
+      </p:sp>
+      <p:sp>
+        <p:nvSpPr>
+          <p:cNvPr id="17" name="Text 15">
+            <a:extLst xmlns:a="http://schemas.openxmlformats.org/drawingml/2006/main">
+              <a:ext uri="{FF2B5EF4-FFF2-40B4-BE49-F238E27FC236}">
+                <a16:creationId xmlns:a16="http://schemas.microsoft.com/office/drawing/2014/main" id="{0A395070-FD19-457A-B079-55F788772E98}"/>
+              </a:ext>
+            </a:extLst>
+          </p:cNvPr>
+          <p:cNvSpPr>
+            <a:spLocks xmlns:a="http://schemas.openxmlformats.org/drawingml/2006/main" noGrp="1"/>
+          </p:cNvSpPr>
+          <p:nvPr/>
+        </p:nvSpPr>
+        <p:spPr>
+          <a:xfrm xmlns:a="http://schemas.openxmlformats.org/drawingml/2006/main">
             <a:off x="1510109" y="3231952"/>
             <a:ext cx="4442226" cy="238720"/>
           </a:xfrm>
-          <a:prstGeom prst="rect">
-            <a:avLst/>
-          </a:prstGeom>
-          <a:noFill/>
-          <a:ln/>
-        </p:spPr>
-        <p:txBody>
-          <a:bodyPr wrap="square" lIns="0" tIns="0" rIns="0" bIns="0" rtlCol="0" anchor="t">
-            <a:normAutofit/>
-          </a:bodyPr>
-          <a:lstStyle/>
-          <a:p>
-            <a:pPr algn="l" indent="0" marL="0">
+          <a:prstGeom xmlns:a="http://schemas.openxmlformats.org/drawingml/2006/main" prst="rect">
+            <a:avLst/>
+          </a:prstGeom>
+          <a:noFill xmlns:a="http://schemas.openxmlformats.org/drawingml/2006/main"/>
+        </p:spPr>
+        <p:txBody>
+          <a:bodyPr xmlns:a="http://schemas.openxmlformats.org/drawingml/2006/main" wrap="square" lIns="0" tIns="0" rIns="0" bIns="0" anchor="t">
+            <a:normAutofit/>
+          </a:bodyPr>
+          <a:lstStyle xmlns:a="http://schemas.openxmlformats.org/drawingml/2006/main"/>
+          <a:p xmlns:a="http://schemas.openxmlformats.org/drawingml/2006/main">
+            <a:pPr marL="0" indent="0" algn="l">
               <a:lnSpc>
                 <a:spcPts val="1680"/>
               </a:lnSpc>
               <a:buNone/>
             </a:pPr>
             <a:r>
-              <a:rPr lang="en-US" sz="1400" b="1" dirty="0">
+              <a:rPr sz="1400" b="1">
                 <a:solidFill>
                   <a:srgbClr val="13202D"/>
                 </a:solidFill>
-                <a:latin typeface="IBM Plex Sans" pitchFamily="34" charset="0"/>
-                <a:ea typeface="IBM Plex Sans" pitchFamily="34" charset="-122"/>
-                <a:cs typeface="IBM Plex Sans" pitchFamily="34" charset="-120"/>
+                <a:latin typeface="IBM Plex Sans"/>
+                <a:ea typeface="IBM Plex Sans"/>
+                <a:cs typeface="IBM Plex Sans"/>
               </a:rPr>
               <a:t>Pull Request</a:t>
             </a:r>
-            <a:endParaRPr lang="en-US" sz="1400" dirty="0"/>
-          </a:p>
-        </p:txBody>
-      </p:sp>
-      <p:sp>
-        <p:nvSpPr>
-          <p:cNvPr id="18" name="Text 16"/>
-          <p:cNvSpPr/>
-          <p:nvPr/>
-        </p:nvSpPr>
-        <p:spPr>
-          <a:xfrm>
+            <a:endParaRPr sz="1400"/>
+          </a:p>
+        </p:txBody>
+      </p:sp>
+      <p:sp>
+        <p:nvSpPr>
+          <p:cNvPr id="18" name="Text 16">
+            <a:extLst xmlns:a="http://schemas.openxmlformats.org/drawingml/2006/main">
+              <a:ext uri="{FF2B5EF4-FFF2-40B4-BE49-F238E27FC236}">
+                <a16:creationId xmlns:a16="http://schemas.microsoft.com/office/drawing/2014/main" id="{BCFDAD02-3495-400E-AF7E-3B5CD2ED72C6}"/>
+              </a:ext>
+            </a:extLst>
+          </p:cNvPr>
+          <p:cNvSpPr>
+            <a:spLocks xmlns:a="http://schemas.openxmlformats.org/drawingml/2006/main" noGrp="1"/>
+          </p:cNvSpPr>
+          <p:nvPr/>
+        </p:nvSpPr>
+        <p:spPr>
+          <a:xfrm xmlns:a="http://schemas.openxmlformats.org/drawingml/2006/main">
             <a:off x="1510109" y="3483372"/>
             <a:ext cx="4442226" cy="238720"/>
           </a:xfrm>
-          <a:prstGeom prst="rect">
-            <a:avLst/>
-          </a:prstGeom>
-          <a:noFill/>
-          <a:ln/>
-        </p:spPr>
-        <p:txBody>
-          <a:bodyPr wrap="square" lIns="0" tIns="0" rIns="0" bIns="0" rtlCol="0" anchor="t">
-            <a:normAutofit/>
-          </a:bodyPr>
-          <a:lstStyle/>
-          <a:p>
-            <a:pPr algn="l" indent="0" marL="0">
+          <a:prstGeom xmlns:a="http://schemas.openxmlformats.org/drawingml/2006/main" prst="rect">
+            <a:avLst/>
+          </a:prstGeom>
+          <a:noFill xmlns:a="http://schemas.openxmlformats.org/drawingml/2006/main"/>
+        </p:spPr>
+        <p:txBody>
+          <a:bodyPr xmlns:a="http://schemas.openxmlformats.org/drawingml/2006/main" wrap="square" lIns="0" tIns="0" rIns="0" bIns="0" anchor="t">
+            <a:normAutofit/>
+          </a:bodyPr>
+          <a:lstStyle xmlns:a="http://schemas.openxmlformats.org/drawingml/2006/main"/>
+          <a:p xmlns:a="http://schemas.openxmlformats.org/drawingml/2006/main">
+            <a:pPr marL="0" indent="0" algn="l">
               <a:lnSpc>
                 <a:spcPts val="1680"/>
               </a:lnSpc>
               <a:buNone/>
             </a:pPr>
             <a:r>
-              <a:rPr lang="en-US" sz="1200" dirty="0">
+              <a:rPr sz="1200">
                 <a:solidFill>
                   <a:srgbClr val="44505D"/>
                 </a:solidFill>
-                <a:latin typeface="IBM Plex Sans" pitchFamily="34" charset="0"/>
-                <a:ea typeface="IBM Plex Sans" pitchFamily="34" charset="-122"/>
-                <a:cs typeface="IBM Plex Sans" pitchFamily="34" charset="-120"/>
+                <a:latin typeface="IBM Plex Sans"/>
+                <a:ea typeface="IBM Plex Sans"/>
+                <a:cs typeface="IBM Plex Sans"/>
               </a:rPr>
               <a:t>преглед измена и образложени коментари</a:t>
             </a:r>
-            <a:endParaRPr lang="en-US" sz="1200" dirty="0"/>
-          </a:p>
-        </p:txBody>
-      </p:sp>
-      <p:sp>
-        <p:nvSpPr>
-          <p:cNvPr id="19" name="Shape 17"/>
-          <p:cNvSpPr/>
-          <p:nvPr/>
-        </p:nvSpPr>
-        <p:spPr>
-          <a:xfrm>
+            <a:endParaRPr sz="1200"/>
+          </a:p>
+        </p:txBody>
+      </p:sp>
+      <p:sp>
+        <p:nvSpPr>
+          <p:cNvPr id="19" name="Shape 17">
+            <a:extLst xmlns:a="http://schemas.openxmlformats.org/drawingml/2006/main">
+              <a:ext uri="{FF2B5EF4-FFF2-40B4-BE49-F238E27FC236}">
+                <a16:creationId xmlns:a16="http://schemas.microsoft.com/office/drawing/2014/main" id="{EDC287F8-0B99-4AE4-9AE3-87A79E74479C}"/>
+              </a:ext>
+            </a:extLst>
+          </p:cNvPr>
+          <p:cNvSpPr>
+            <a:spLocks xmlns:a="http://schemas.openxmlformats.org/drawingml/2006/main" noGrp="1"/>
+          </p:cNvSpPr>
+          <p:nvPr/>
+        </p:nvSpPr>
+        <p:spPr>
+          <a:xfrm xmlns:a="http://schemas.openxmlformats.org/drawingml/2006/main">
             <a:off x="6162675" y="3063677"/>
             <a:ext cx="5213350" cy="801291"/>
           </a:xfrm>
-          <a:prstGeom prst="roundRect">
+          <a:prstGeom xmlns:a="http://schemas.openxmlformats.org/drawingml/2006/main" prst="roundRect">
             <a:avLst>
               <a:gd name="adj" fmla="val 12283"/>
             </a:avLst>
           </a:prstGeom>
-          <a:solidFill>
+          <a:solidFill xmlns:a="http://schemas.openxmlformats.org/drawingml/2006/main">
             <a:srgbClr val="FCFCFB"/>
           </a:solidFill>
-          <a:ln w="6350">
+          <a:ln xmlns:a="http://schemas.openxmlformats.org/drawingml/2006/main" w="6350">
             <a:solidFill>
               <a:srgbClr val="D3DAE1"/>
             </a:solidFill>
@@ -33415,152 +33506,181 @@
       </p:sp>
       <p:sp>
         <p:nvSpPr>
-          <p:cNvPr id="20" name="Text 18"/>
-          <p:cNvSpPr/>
-          <p:nvPr/>
-        </p:nvSpPr>
-        <p:spPr>
-          <a:xfrm>
+          <p:cNvPr id="20" name="Text 18">
+            <a:extLst xmlns:a="http://schemas.openxmlformats.org/drawingml/2006/main">
+              <a:ext uri="{FF2B5EF4-FFF2-40B4-BE49-F238E27FC236}">
+                <a16:creationId xmlns:a16="http://schemas.microsoft.com/office/drawing/2014/main" id="{E34B58B1-2A21-4438-8085-D6BE9CB497A1}"/>
+              </a:ext>
+            </a:extLst>
+          </p:cNvPr>
+          <p:cNvSpPr>
+            <a:spLocks xmlns:a="http://schemas.openxmlformats.org/drawingml/2006/main" noGrp="1"/>
+          </p:cNvSpPr>
+          <p:nvPr/>
+        </p:nvSpPr>
+        <p:spPr>
+          <a:xfrm xmlns:a="http://schemas.openxmlformats.org/drawingml/2006/main">
             <a:off x="6369050" y="3231952"/>
             <a:ext cx="402431" cy="332680"/>
           </a:xfrm>
-          <a:prstGeom prst="rect">
-            <a:avLst/>
-          </a:prstGeom>
-          <a:noFill/>
-          <a:ln/>
-        </p:spPr>
-        <p:txBody>
-          <a:bodyPr wrap="square" lIns="0" tIns="0" rIns="0" bIns="0" rtlCol="0" anchor="t">
-            <a:normAutofit/>
-          </a:bodyPr>
-          <a:lstStyle/>
-          <a:p>
-            <a:pPr algn="l" indent="0" marL="0">
+          <a:prstGeom xmlns:a="http://schemas.openxmlformats.org/drawingml/2006/main" prst="rect">
+            <a:avLst/>
+          </a:prstGeom>
+          <a:noFill xmlns:a="http://schemas.openxmlformats.org/drawingml/2006/main"/>
+        </p:spPr>
+        <p:txBody>
+          <a:bodyPr xmlns:a="http://schemas.openxmlformats.org/drawingml/2006/main" wrap="square" lIns="0" tIns="0" rIns="0" bIns="0" anchor="t">
+            <a:normAutofit/>
+          </a:bodyPr>
+          <a:lstStyle xmlns:a="http://schemas.openxmlformats.org/drawingml/2006/main"/>
+          <a:p xmlns:a="http://schemas.openxmlformats.org/drawingml/2006/main">
+            <a:pPr marL="0" indent="0" algn="l">
               <a:lnSpc>
                 <a:spcPts val="2420"/>
               </a:lnSpc>
               <a:buNone/>
             </a:pPr>
             <a:r>
-              <a:rPr lang="en-US" sz="2200" dirty="0">
+              <a:rPr sz="2200">
                 <a:solidFill>
                   <a:srgbClr val="0E6E68"/>
                 </a:solidFill>
-                <a:latin typeface="IBM Plex Mono" pitchFamily="49" charset="0"/>
-                <a:ea typeface="IBM Plex Mono" pitchFamily="49" charset="-122"/>
-                <a:cs typeface="IBM Plex Mono" pitchFamily="49" charset="-120"/>
+                <a:latin typeface="IBM Plex Mono"/>
+                <a:ea typeface="IBM Plex Mono"/>
+                <a:cs typeface="IBM Plex Mono"/>
               </a:rPr>
               <a:t>04</a:t>
             </a:r>
-            <a:endParaRPr lang="en-US" sz="2200" dirty="0"/>
-          </a:p>
-        </p:txBody>
-      </p:sp>
-      <p:sp>
-        <p:nvSpPr>
-          <p:cNvPr id="21" name="Text 19"/>
-          <p:cNvSpPr/>
-          <p:nvPr/>
-        </p:nvSpPr>
-        <p:spPr>
-          <a:xfrm>
+            <a:endParaRPr sz="2200"/>
+          </a:p>
+        </p:txBody>
+      </p:sp>
+      <p:sp>
+        <p:nvSpPr>
+          <p:cNvPr id="21" name="Text 19">
+            <a:extLst xmlns:a="http://schemas.openxmlformats.org/drawingml/2006/main">
+              <a:ext uri="{FF2B5EF4-FFF2-40B4-BE49-F238E27FC236}">
+                <a16:creationId xmlns:a16="http://schemas.microsoft.com/office/drawing/2014/main" id="{70B5CB73-0FB8-42E2-AAE9-D22BC41EF442}"/>
+              </a:ext>
+            </a:extLst>
+          </p:cNvPr>
+          <p:cNvSpPr>
+            <a:spLocks xmlns:a="http://schemas.openxmlformats.org/drawingml/2006/main" noGrp="1"/>
+          </p:cNvSpPr>
+          <p:nvPr/>
+        </p:nvSpPr>
+        <p:spPr>
+          <a:xfrm xmlns:a="http://schemas.openxmlformats.org/drawingml/2006/main">
             <a:off x="6856809" y="3231952"/>
             <a:ext cx="4442226" cy="238720"/>
           </a:xfrm>
-          <a:prstGeom prst="rect">
-            <a:avLst/>
-          </a:prstGeom>
-          <a:noFill/>
-          <a:ln/>
-        </p:spPr>
-        <p:txBody>
-          <a:bodyPr wrap="square" lIns="0" tIns="0" rIns="0" bIns="0" rtlCol="0" anchor="t">
-            <a:normAutofit/>
-          </a:bodyPr>
-          <a:lstStyle/>
-          <a:p>
-            <a:pPr algn="l" indent="0" marL="0">
+          <a:prstGeom xmlns:a="http://schemas.openxmlformats.org/drawingml/2006/main" prst="rect">
+            <a:avLst/>
+          </a:prstGeom>
+          <a:noFill xmlns:a="http://schemas.openxmlformats.org/drawingml/2006/main"/>
+        </p:spPr>
+        <p:txBody>
+          <a:bodyPr xmlns:a="http://schemas.openxmlformats.org/drawingml/2006/main" wrap="square" lIns="0" tIns="0" rIns="0" bIns="0" anchor="t">
+            <a:normAutofit/>
+          </a:bodyPr>
+          <a:lstStyle xmlns:a="http://schemas.openxmlformats.org/drawingml/2006/main"/>
+          <a:p xmlns:a="http://schemas.openxmlformats.org/drawingml/2006/main">
+            <a:pPr marL="0" indent="0" algn="l">
               <a:lnSpc>
                 <a:spcPts val="1680"/>
               </a:lnSpc>
               <a:buNone/>
             </a:pPr>
             <a:r>
-              <a:rPr lang="en-US" sz="1400" b="1" dirty="0">
+              <a:rPr sz="1400" b="1">
                 <a:solidFill>
                   <a:srgbClr val="13202D"/>
                 </a:solidFill>
-                <a:latin typeface="IBM Plex Sans" pitchFamily="34" charset="0"/>
-                <a:ea typeface="IBM Plex Sans" pitchFamily="34" charset="-122"/>
-                <a:cs typeface="IBM Plex Sans" pitchFamily="34" charset="-120"/>
+                <a:latin typeface="IBM Plex Sans"/>
+                <a:ea typeface="IBM Plex Sans"/>
+                <a:cs typeface="IBM Plex Sans"/>
               </a:rPr>
               <a:t>Договорени ток</a:t>
             </a:r>
-            <a:endParaRPr lang="en-US" sz="1400" dirty="0"/>
-          </a:p>
-        </p:txBody>
-      </p:sp>
-      <p:sp>
-        <p:nvSpPr>
-          <p:cNvPr id="22" name="Text 20"/>
-          <p:cNvSpPr/>
-          <p:nvPr/>
-        </p:nvSpPr>
-        <p:spPr>
-          <a:xfrm>
+            <a:endParaRPr sz="1400"/>
+          </a:p>
+        </p:txBody>
+      </p:sp>
+      <p:sp>
+        <p:nvSpPr>
+          <p:cNvPr id="22" name="Text 20">
+            <a:extLst xmlns:a="http://schemas.openxmlformats.org/drawingml/2006/main">
+              <a:ext uri="{FF2B5EF4-FFF2-40B4-BE49-F238E27FC236}">
+                <a16:creationId xmlns:a16="http://schemas.microsoft.com/office/drawing/2014/main" id="{34D19A0B-58DF-4566-97DF-B4D373A43858}"/>
+              </a:ext>
+            </a:extLst>
+          </p:cNvPr>
+          <p:cNvSpPr>
+            <a:spLocks xmlns:a="http://schemas.openxmlformats.org/drawingml/2006/main" noGrp="1"/>
+          </p:cNvSpPr>
+          <p:nvPr/>
+        </p:nvSpPr>
+        <p:spPr>
+          <a:xfrm xmlns:a="http://schemas.openxmlformats.org/drawingml/2006/main">
             <a:off x="6856809" y="3483372"/>
             <a:ext cx="4442226" cy="238720"/>
           </a:xfrm>
-          <a:prstGeom prst="rect">
-            <a:avLst/>
-          </a:prstGeom>
-          <a:noFill/>
-          <a:ln/>
-        </p:spPr>
-        <p:txBody>
-          <a:bodyPr wrap="square" lIns="0" tIns="0" rIns="0" bIns="0" rtlCol="0" anchor="t">
-            <a:normAutofit/>
-          </a:bodyPr>
-          <a:lstStyle/>
-          <a:p>
-            <a:pPr algn="l" indent="0" marL="0">
+          <a:prstGeom xmlns:a="http://schemas.openxmlformats.org/drawingml/2006/main" prst="rect">
+            <a:avLst/>
+          </a:prstGeom>
+          <a:noFill xmlns:a="http://schemas.openxmlformats.org/drawingml/2006/main"/>
+        </p:spPr>
+        <p:txBody>
+          <a:bodyPr xmlns:a="http://schemas.openxmlformats.org/drawingml/2006/main" wrap="square" lIns="0" tIns="0" rIns="0" bIns="0" anchor="t">
+            <a:normAutofit/>
+          </a:bodyPr>
+          <a:lstStyle xmlns:a="http://schemas.openxmlformats.org/drawingml/2006/main"/>
+          <a:p xmlns:a="http://schemas.openxmlformats.org/drawingml/2006/main">
+            <a:pPr marL="0" indent="0" algn="l">
               <a:lnSpc>
                 <a:spcPts val="1680"/>
               </a:lnSpc>
               <a:buNone/>
             </a:pPr>
             <a:r>
-              <a:rPr lang="en-US" sz="1200" dirty="0">
+              <a:rPr sz="1200">
                 <a:solidFill>
                   <a:srgbClr val="44505D"/>
                 </a:solidFill>
-                <a:latin typeface="IBM Plex Sans" pitchFamily="34" charset="0"/>
-                <a:ea typeface="IBM Plex Sans" pitchFamily="34" charset="-122"/>
-                <a:cs typeface="IBM Plex Sans" pitchFamily="34" charset="-120"/>
+                <a:latin typeface="IBM Plex Sans"/>
+                <a:ea typeface="IBM Plex Sans"/>
+                <a:cs typeface="IBM Plex Sans"/>
               </a:rPr>
               <a:t>од Backlog до Done, кроз Review и QA</a:t>
             </a:r>
-            <a:endParaRPr lang="en-US" sz="1200" dirty="0"/>
-          </a:p>
-        </p:txBody>
-      </p:sp>
-      <p:sp>
-        <p:nvSpPr>
-          <p:cNvPr id="23" name="Shape 21"/>
-          <p:cNvSpPr/>
-          <p:nvPr/>
-        </p:nvSpPr>
-        <p:spPr>
-          <a:xfrm>
+            <a:endParaRPr sz="1200"/>
+          </a:p>
+        </p:txBody>
+      </p:sp>
+      <p:sp>
+        <p:nvSpPr>
+          <p:cNvPr id="23" name="Shape 21">
+            <a:extLst xmlns:a="http://schemas.openxmlformats.org/drawingml/2006/main">
+              <a:ext uri="{FF2B5EF4-FFF2-40B4-BE49-F238E27FC236}">
+                <a16:creationId xmlns:a16="http://schemas.microsoft.com/office/drawing/2014/main" id="{AFEEB5B5-0A03-4F67-93D7-9543E26B6FD9}"/>
+              </a:ext>
+            </a:extLst>
+          </p:cNvPr>
+          <p:cNvSpPr>
+            <a:spLocks xmlns:a="http://schemas.openxmlformats.org/drawingml/2006/main" noGrp="1"/>
+          </p:cNvSpPr>
+          <p:nvPr/>
+        </p:nvSpPr>
+        <p:spPr>
+          <a:xfrm xmlns:a="http://schemas.openxmlformats.org/drawingml/2006/main">
             <a:off x="812800" y="6209705"/>
             <a:ext cx="10566400" cy="0"/>
           </a:xfrm>
-          <a:prstGeom prst="line">
-            <a:avLst/>
-          </a:prstGeom>
-          <a:noFill/>
-          <a:ln w="6350">
+          <a:prstGeom xmlns:a="http://schemas.openxmlformats.org/drawingml/2006/main" prst="line">
+            <a:avLst/>
+          </a:prstGeom>
+          <a:noFill xmlns:a="http://schemas.openxmlformats.org/drawingml/2006/main"/>
+          <a:ln xmlns:a="http://schemas.openxmlformats.org/drawingml/2006/main" w="6350">
             <a:solidFill>
               <a:srgbClr val="D3DAE1"/>
             </a:solidFill>
@@ -33570,97 +33690,113 @@
       </p:sp>
       <p:sp>
         <p:nvSpPr>
-          <p:cNvPr id="24" name="Text 22"/>
-          <p:cNvSpPr/>
-          <p:nvPr/>
-        </p:nvSpPr>
-        <p:spPr>
-          <a:xfrm>
+          <p:cNvPr id="24" name="Text 22">
+            <a:extLst xmlns:a="http://schemas.openxmlformats.org/drawingml/2006/main">
+              <a:ext uri="{FF2B5EF4-FFF2-40B4-BE49-F238E27FC236}">
+                <a16:creationId xmlns:a16="http://schemas.microsoft.com/office/drawing/2014/main" id="{F51A4734-B0E4-456F-A0EF-A76A696201A0}"/>
+              </a:ext>
+            </a:extLst>
+          </p:cNvPr>
+          <p:cNvSpPr>
+            <a:spLocks xmlns:a="http://schemas.openxmlformats.org/drawingml/2006/main" noGrp="1"/>
+          </p:cNvSpPr>
+          <p:nvPr/>
+        </p:nvSpPr>
+        <p:spPr>
+          <a:xfrm xmlns:a="http://schemas.openxmlformats.org/drawingml/2006/main">
             <a:off x="812800" y="6314480"/>
             <a:ext cx="2390061" cy="238720"/>
           </a:xfrm>
-          <a:prstGeom prst="rect">
-            <a:avLst/>
-          </a:prstGeom>
-          <a:noFill/>
-          <a:ln/>
-        </p:spPr>
-        <p:txBody>
-          <a:bodyPr wrap="square" lIns="0" tIns="0" rIns="0" bIns="0" rtlCol="0" anchor="t">
-            <a:normAutofit/>
-          </a:bodyPr>
-          <a:lstStyle/>
-          <a:p>
-            <a:pPr algn="l" indent="0" marL="0">
+          <a:prstGeom xmlns:a="http://schemas.openxmlformats.org/drawingml/2006/main" prst="rect">
+            <a:avLst/>
+          </a:prstGeom>
+          <a:noFill xmlns:a="http://schemas.openxmlformats.org/drawingml/2006/main"/>
+        </p:spPr>
+        <p:txBody>
+          <a:bodyPr xmlns:a="http://schemas.openxmlformats.org/drawingml/2006/main" wrap="square" lIns="0" tIns="0" rIns="0" bIns="0" anchor="t">
+            <a:normAutofit/>
+          </a:bodyPr>
+          <a:lstStyle xmlns:a="http://schemas.openxmlformats.org/drawingml/2006/main"/>
+          <a:p xmlns:a="http://schemas.openxmlformats.org/drawingml/2006/main">
+            <a:pPr marL="0" indent="0" algn="l">
               <a:lnSpc>
                 <a:spcPts val="1680"/>
               </a:lnSpc>
               <a:buNone/>
             </a:pPr>
             <a:r>
-              <a:rPr lang="en-US" sz="1200" dirty="0">
+              <a:rPr sz="1200">
                 <a:solidFill>
                   <a:srgbClr val="5E6975"/>
                 </a:solidFill>
-                <a:latin typeface="IBM Plex Sans" pitchFamily="34" charset="0"/>
-                <a:ea typeface="IBM Plex Sans" pitchFamily="34" charset="-122"/>
-                <a:cs typeface="IBM Plex Sans" pitchFamily="34" charset="-120"/>
+                <a:latin typeface="IBM Plex Sans"/>
+                <a:ea typeface="IBM Plex Sans"/>
+                <a:cs typeface="IBM Plex Sans"/>
               </a:rPr>
               <a:t>Елементи развоја софтвера</a:t>
             </a:r>
-            <a:endParaRPr lang="en-US" sz="1200" dirty="0"/>
-          </a:p>
-        </p:txBody>
-      </p:sp>
-      <p:sp>
-        <p:nvSpPr>
-          <p:cNvPr id="25" name="Text 23"/>
-          <p:cNvSpPr/>
-          <p:nvPr/>
-        </p:nvSpPr>
-        <p:spPr>
-          <a:xfrm>
+            <a:endParaRPr sz="1200"/>
+          </a:p>
+        </p:txBody>
+      </p:sp>
+      <p:sp>
+        <p:nvSpPr>
+          <p:cNvPr id="25" name="Text 23">
+            <a:extLst xmlns:a="http://schemas.openxmlformats.org/drawingml/2006/main">
+              <a:ext uri="{FF2B5EF4-FFF2-40B4-BE49-F238E27FC236}">
+                <a16:creationId xmlns:a16="http://schemas.microsoft.com/office/drawing/2014/main" id="{0289C21F-A7F1-4AEE-8FA7-21055E57DDAD}"/>
+              </a:ext>
+            </a:extLst>
+          </p:cNvPr>
+          <p:cNvSpPr>
+            <a:spLocks xmlns:a="http://schemas.openxmlformats.org/drawingml/2006/main" noGrp="1"/>
+          </p:cNvSpPr>
+          <p:nvPr/>
+        </p:nvSpPr>
+        <p:spPr>
+          <a:xfrm xmlns:a="http://schemas.openxmlformats.org/drawingml/2006/main">
             <a:off x="11145441" y="6314480"/>
             <a:ext cx="233759" cy="238720"/>
           </a:xfrm>
-          <a:prstGeom prst="rect">
-            <a:avLst/>
-          </a:prstGeom>
-          <a:noFill/>
-          <a:ln/>
-        </p:spPr>
-        <p:txBody>
-          <a:bodyPr wrap="square" lIns="0" tIns="0" rIns="0" bIns="0" rtlCol="0" anchor="t">
-            <a:normAutofit/>
-          </a:bodyPr>
-          <a:lstStyle/>
-          <a:p>
-            <a:pPr algn="r" indent="0" marL="0">
+          <a:prstGeom xmlns:a="http://schemas.openxmlformats.org/drawingml/2006/main" prst="rect">
+            <a:avLst/>
+          </a:prstGeom>
+          <a:noFill xmlns:a="http://schemas.openxmlformats.org/drawingml/2006/main"/>
+        </p:spPr>
+        <p:txBody>
+          <a:bodyPr xmlns:a="http://schemas.openxmlformats.org/drawingml/2006/main" wrap="square" lIns="0" tIns="0" rIns="0" bIns="0" anchor="t">
+            <a:normAutofit/>
+          </a:bodyPr>
+          <a:lstStyle xmlns:a="http://schemas.openxmlformats.org/drawingml/2006/main"/>
+          <a:p xmlns:a="http://schemas.openxmlformats.org/drawingml/2006/main">
+            <a:pPr marL="0" indent="0" algn="r">
               <a:lnSpc>
                 <a:spcPts val="1680"/>
               </a:lnSpc>
               <a:buNone/>
             </a:pPr>
             <a:r>
-              <a:rPr lang="en-US" sz="1200" dirty="0">
+              <a:rPr sz="1200">
                 <a:solidFill>
                   <a:srgbClr val="5E6975"/>
                 </a:solidFill>
-                <a:latin typeface="IBM Plex Mono" pitchFamily="49" charset="0"/>
-                <a:ea typeface="IBM Plex Mono" pitchFamily="49" charset="-122"/>
-                <a:cs typeface="IBM Plex Mono" pitchFamily="49" charset="-120"/>
+                <a:latin typeface="IBM Plex Mono"/>
+                <a:ea typeface="IBM Plex Mono"/>
+                <a:cs typeface="IBM Plex Mono"/>
               </a:rPr>
               <a:t>32</a:t>
             </a:r>
-            <a:endParaRPr lang="en-US" sz="1200" dirty="0"/>
+            <a:endParaRPr sz="1200"/>
           </a:p>
         </p:txBody>
       </p:sp>
     </p:spTree>
+    <p:extLst>
+      <p:ext uri="{BB962C8B-B14F-4D97-AF65-F5344CB8AC3E}">
+        <p14:creationId xmlns:p14="http://schemas.microsoft.com/office/powerpoint/2010/main" val="183690279"/>
+      </p:ext>
+    </p:extLst>
   </p:cSld>
-  <p:clrMapOvr>
-    <a:masterClrMapping/>
-  </p:clrMapOvr>
 </p:sld>
 </file>
 
@@ -37257,11 +37393,11 @@
 </file>
 
 <file path=ppt/slides/slide37.xml><?xml version="1.0" encoding="utf-8"?>
-<p:sld xmlns:a="http://schemas.openxmlformats.org/drawingml/2006/main" xmlns:r="http://schemas.openxmlformats.org/officeDocument/2006/relationships" xmlns:p="http://schemas.openxmlformats.org/presentationml/2006/main">
-  <p:cSld name="Slide 37">
+<p:sld xmlns:p="http://schemas.openxmlformats.org/presentationml/2006/main">
+  <p:cSld>
     <p:bg>
       <p:bgPr>
-        <a:solidFill>
+        <a:solidFill xmlns:a="http://schemas.openxmlformats.org/drawingml/2006/main">
           <a:srgbClr val="F6F7F5"/>
         </a:solidFill>
       </p:bgPr>
@@ -37273,189 +37409,220 @@
         <p:nvPr/>
       </p:nvGrpSpPr>
       <p:grpSpPr>
-        <a:xfrm>
-          <a:off x="0" y="0"/>
-          <a:ext cx="0" cy="0"/>
-          <a:chOff x="0" y="0"/>
-          <a:chExt cx="0" cy="0"/>
-        </a:xfrm>
+        <a:xfrm xmlns:a="http://schemas.openxmlformats.org/drawingml/2006/main"/>
       </p:grpSpPr>
       <p:sp>
         <p:nvSpPr>
-          <p:cNvPr id="2" name="Shape 0"/>
-          <p:cNvSpPr/>
-          <p:nvPr/>
-        </p:nvSpPr>
-        <p:spPr>
-          <a:xfrm>
+          <p:cNvPr id="2" name="Shape 0">
+            <a:extLst xmlns:a="http://schemas.openxmlformats.org/drawingml/2006/main">
+              <a:ext uri="{FF2B5EF4-FFF2-40B4-BE49-F238E27FC236}">
+                <a16:creationId xmlns:a16="http://schemas.microsoft.com/office/drawing/2014/main" id="{D73B2266-50A0-4C08-B426-DB1F7592E818}"/>
+              </a:ext>
+            </a:extLst>
+          </p:cNvPr>
+          <p:cNvSpPr>
+            <a:spLocks xmlns:a="http://schemas.openxmlformats.org/drawingml/2006/main" noGrp="1"/>
+          </p:cNvSpPr>
+          <p:nvPr/>
+        </p:nvSpPr>
+        <p:spPr>
+          <a:xfrm xmlns:a="http://schemas.openxmlformats.org/drawingml/2006/main">
             <a:off x="812800" y="457200"/>
             <a:ext cx="457200" cy="38100"/>
           </a:xfrm>
-          <a:prstGeom prst="roundRect">
+          <a:prstGeom xmlns:a="http://schemas.openxmlformats.org/drawingml/2006/main" prst="roundRect">
             <a:avLst>
               <a:gd name="adj" fmla="val 50000"/>
             </a:avLst>
           </a:prstGeom>
-          <a:solidFill>
+          <a:solidFill xmlns:a="http://schemas.openxmlformats.org/drawingml/2006/main">
             <a:srgbClr val="0E6E68"/>
           </a:solidFill>
-          <a:ln/>
-        </p:spPr>
-      </p:sp>
-      <p:sp>
-        <p:nvSpPr>
-          <p:cNvPr id="3" name="Text 1"/>
-          <p:cNvSpPr/>
-          <p:nvPr/>
-        </p:nvSpPr>
-        <p:spPr>
-          <a:xfrm>
+        </p:spPr>
+      </p:sp>
+      <p:sp>
+        <p:nvSpPr>
+          <p:cNvPr id="3" name="Text 1">
+            <a:extLst xmlns:a="http://schemas.openxmlformats.org/drawingml/2006/main">
+              <a:ext uri="{FF2B5EF4-FFF2-40B4-BE49-F238E27FC236}">
+                <a16:creationId xmlns:a16="http://schemas.microsoft.com/office/drawing/2014/main" id="{EC8F99A0-FED9-4F96-A0A0-229CEFAEF5CE}"/>
+              </a:ext>
+            </a:extLst>
+          </p:cNvPr>
+          <p:cNvSpPr>
+            <a:spLocks xmlns:a="http://schemas.openxmlformats.org/drawingml/2006/main" noGrp="1"/>
+          </p:cNvSpPr>
+          <p:nvPr/>
+        </p:nvSpPr>
+        <p:spPr>
+          <a:xfrm xmlns:a="http://schemas.openxmlformats.org/drawingml/2006/main">
             <a:off x="812800" y="711200"/>
             <a:ext cx="10883392" cy="238720"/>
           </a:xfrm>
-          <a:prstGeom prst="rect">
-            <a:avLst/>
-          </a:prstGeom>
-          <a:noFill/>
-          <a:ln/>
-        </p:spPr>
-        <p:txBody>
-          <a:bodyPr wrap="square" lIns="0" tIns="0" rIns="0" bIns="0" rtlCol="0" anchor="t">
-            <a:normAutofit/>
-          </a:bodyPr>
-          <a:lstStyle/>
-          <a:p>
-            <a:pPr algn="l" indent="0" marL="0">
+          <a:prstGeom xmlns:a="http://schemas.openxmlformats.org/drawingml/2006/main" prst="rect">
+            <a:avLst/>
+          </a:prstGeom>
+          <a:noFill xmlns:a="http://schemas.openxmlformats.org/drawingml/2006/main"/>
+        </p:spPr>
+        <p:txBody>
+          <a:bodyPr xmlns:a="http://schemas.openxmlformats.org/drawingml/2006/main" wrap="square" lIns="0" tIns="0" rIns="0" bIns="0" anchor="t">
+            <a:normAutofit/>
+          </a:bodyPr>
+          <a:lstStyle xmlns:a="http://schemas.openxmlformats.org/drawingml/2006/main"/>
+          <a:p xmlns:a="http://schemas.openxmlformats.org/drawingml/2006/main">
+            <a:pPr marL="0" indent="0" algn="l">
               <a:lnSpc>
                 <a:spcPts val="1680"/>
               </a:lnSpc>
               <a:buNone/>
             </a:pPr>
             <a:r>
-              <a:rPr lang="en-US" sz="1200" spc="100" kern="0" dirty="0">
+              <a:rPr sz="1200" spc="100">
                 <a:solidFill>
                   <a:srgbClr val="0E6E68"/>
                 </a:solidFill>
-                <a:latin typeface="IBM Plex Mono" pitchFamily="49" charset="0"/>
-                <a:ea typeface="IBM Plex Mono" pitchFamily="49" charset="-122"/>
-                <a:cs typeface="IBM Plex Mono" pitchFamily="49" charset="-120"/>
+                <a:latin typeface="IBM Plex Mono"/>
+                <a:ea typeface="IBM Plex Mono"/>
+                <a:cs typeface="IBM Plex Mono"/>
               </a:rPr>
               <a:t>05 · ПРЕДАЈА И КТ1</a:t>
             </a:r>
-            <a:endParaRPr lang="en-US" sz="1200" dirty="0"/>
-          </a:p>
-        </p:txBody>
-      </p:sp>
-      <p:sp>
-        <p:nvSpPr>
-          <p:cNvPr id="4" name="Text 2"/>
-          <p:cNvSpPr/>
+            <a:endParaRPr sz="1200"/>
+          </a:p>
+        </p:txBody>
+      </p:sp>
+      <p:sp>
+        <p:nvSpPr>
+          <p:cNvPr id="4" name="Text 2">
+            <a:extLst xmlns:a="http://schemas.openxmlformats.org/drawingml/2006/main">
+              <a:ext uri="{FF2B5EF4-FFF2-40B4-BE49-F238E27FC236}">
+                <a16:creationId xmlns:a16="http://schemas.microsoft.com/office/drawing/2014/main" id="{812EB57D-9D88-4793-8ABE-67A9CA03EE1D}"/>
+              </a:ext>
+            </a:extLst>
+          </p:cNvPr>
+          <p:cNvSpPr>
+            <a:spLocks xmlns:a="http://schemas.openxmlformats.org/drawingml/2006/main" noGrp="1"/>
+          </p:cNvSpPr>
           <p:nvPr>
-            <p:ph type="title"/>
+            <p:ph type="title" idx="0"/>
           </p:nvPr>
         </p:nvSpPr>
         <p:spPr>
-          <a:xfrm>
+          <a:xfrm xmlns:a="http://schemas.openxmlformats.org/drawingml/2006/main">
             <a:off x="812800" y="1000720"/>
             <a:ext cx="10883392" cy="444500"/>
           </a:xfrm>
-          <a:prstGeom prst="rect">
-            <a:avLst/>
-          </a:prstGeom>
-          <a:noFill/>
-          <a:ln/>
-        </p:spPr>
-        <p:txBody>
-          <a:bodyPr wrap="square" lIns="0" tIns="0" rIns="0" bIns="0" rtlCol="0" anchor="t">
-            <a:normAutofit/>
-          </a:bodyPr>
-          <a:lstStyle/>
-          <a:p>
-            <a:pPr algn="l" indent="0" marL="0">
+          <a:prstGeom xmlns:a="http://schemas.openxmlformats.org/drawingml/2006/main" prst="rect">
+            <a:avLst/>
+          </a:prstGeom>
+          <a:noFill xmlns:a="http://schemas.openxmlformats.org/drawingml/2006/main"/>
+        </p:spPr>
+        <p:txBody>
+          <a:bodyPr xmlns:a="http://schemas.openxmlformats.org/drawingml/2006/main" wrap="square" lIns="0" tIns="0" rIns="0" bIns="0" anchor="t">
+            <a:normAutofit/>
+          </a:bodyPr>
+          <a:lstStyle xmlns:a="http://schemas.openxmlformats.org/drawingml/2006/main"/>
+          <a:p xmlns:a="http://schemas.openxmlformats.org/drawingml/2006/main">
+            <a:pPr marL="0" indent="0" algn="l">
               <a:lnSpc>
                 <a:spcPts val="3300"/>
               </a:lnSpc>
               <a:buNone/>
             </a:pPr>
             <a:r>
-              <a:rPr lang="en-US" sz="3000" b="1" i="0" spc="-50" kern="0" dirty="0">
+              <a:rPr sz="3000" b="1" i="0" spc="-50">
                 <a:solidFill>
                   <a:srgbClr val="13202D"/>
                 </a:solidFill>
-                <a:latin typeface="IBM Plex Sans" pitchFamily="34" charset="0"/>
-                <a:ea typeface="IBM Plex Sans" pitchFamily="34" charset="-122"/>
-                <a:cs typeface="IBM Plex Sans" pitchFamily="34" charset="-120"/>
+                <a:latin typeface="IBM Plex Sans"/>
+                <a:ea typeface="IBM Plex Sans"/>
+                <a:cs typeface="IBM Plex Sans"/>
               </a:rPr>
               <a:t>Припрема за наредну вежбу</a:t>
             </a:r>
-            <a:endParaRPr lang="en-US" sz="3000" dirty="0"/>
-          </a:p>
-        </p:txBody>
-      </p:sp>
-      <p:sp>
-        <p:nvSpPr>
-          <p:cNvPr id="5" name="Text 3"/>
-          <p:cNvSpPr/>
-          <p:nvPr/>
-        </p:nvSpPr>
-        <p:spPr>
-          <a:xfrm>
+            <a:endParaRPr sz="3000"/>
+          </a:p>
+        </p:txBody>
+      </p:sp>
+      <p:sp>
+        <p:nvSpPr>
+          <p:cNvPr id="5" name="Text 3">
+            <a:extLst xmlns:a="http://schemas.openxmlformats.org/drawingml/2006/main">
+              <a:ext uri="{FF2B5EF4-FFF2-40B4-BE49-F238E27FC236}">
+                <a16:creationId xmlns:a16="http://schemas.microsoft.com/office/drawing/2014/main" id="{F515B219-3037-43B3-A5C5-A5B6F494B907}"/>
+              </a:ext>
+            </a:extLst>
+          </p:cNvPr>
+          <p:cNvSpPr>
+            <a:spLocks xmlns:a="http://schemas.openxmlformats.org/drawingml/2006/main" noGrp="1"/>
+          </p:cNvSpPr>
+          <p:nvPr/>
+        </p:nvSpPr>
+        <p:spPr>
+          <a:xfrm xmlns:a="http://schemas.openxmlformats.org/drawingml/2006/main">
             <a:off x="812800" y="1648420"/>
             <a:ext cx="10883392" cy="274241"/>
           </a:xfrm>
-          <a:prstGeom prst="rect">
-            <a:avLst/>
-          </a:prstGeom>
-          <a:noFill/>
-          <a:ln/>
-        </p:spPr>
-        <p:txBody>
-          <a:bodyPr wrap="square" lIns="0" tIns="0" rIns="0" bIns="0" rtlCol="0" anchor="t">
-            <a:normAutofit/>
-          </a:bodyPr>
-          <a:lstStyle/>
-          <a:p>
-            <a:pPr algn="l" indent="0" marL="0">
+          <a:prstGeom xmlns:a="http://schemas.openxmlformats.org/drawingml/2006/main" prst="rect">
+            <a:avLst/>
+          </a:prstGeom>
+          <a:noFill xmlns:a="http://schemas.openxmlformats.org/drawingml/2006/main"/>
+        </p:spPr>
+        <p:txBody>
+          <a:bodyPr xmlns:a="http://schemas.openxmlformats.org/drawingml/2006/main" wrap="square" lIns="0" tIns="0" rIns="0" bIns="0" anchor="t">
+            <a:normAutofit/>
+          </a:bodyPr>
+          <a:lstStyle xmlns:a="http://schemas.openxmlformats.org/drawingml/2006/main"/>
+          <a:p xmlns:a="http://schemas.openxmlformats.org/drawingml/2006/main">
+            <a:pPr marL="0" indent="0" algn="l">
               <a:lnSpc>
                 <a:spcPts val="1960"/>
               </a:lnSpc>
               <a:buNone/>
             </a:pPr>
             <a:r>
-              <a:rPr lang="en-US" sz="1400" dirty="0">
+              <a:rPr sz="1400">
                 <a:solidFill>
                   <a:srgbClr val="44505D"/>
                 </a:solidFill>
-                <a:latin typeface="IBM Plex Sans" pitchFamily="34" charset="0"/>
-                <a:ea typeface="IBM Plex Sans" pitchFamily="34" charset="-122"/>
-                <a:cs typeface="IBM Plex Sans" pitchFamily="34" charset="-120"/>
+                <a:latin typeface="IBM Plex Sans"/>
+                <a:ea typeface="IBM Plex Sans"/>
+                <a:cs typeface="IBM Plex Sans"/>
               </a:rPr>
               <a:t>Резултати прве вежбе користе се у даљем раду на пројекту.</a:t>
             </a:r>
-            <a:endParaRPr lang="en-US" sz="1400" dirty="0"/>
-          </a:p>
-        </p:txBody>
-      </p:sp>
-      <p:sp>
-        <p:nvSpPr>
-          <p:cNvPr id="6" name="Shape 4"/>
-          <p:cNvSpPr/>
-          <p:nvPr/>
-        </p:nvSpPr>
-        <p:spPr>
-          <a:xfrm>
+            <a:endParaRPr sz="1400"/>
+          </a:p>
+        </p:txBody>
+      </p:sp>
+      <p:sp>
+        <p:nvSpPr>
+          <p:cNvPr id="6" name="Shape 4">
+            <a:extLst xmlns:a="http://schemas.openxmlformats.org/drawingml/2006/main">
+              <a:ext uri="{FF2B5EF4-FFF2-40B4-BE49-F238E27FC236}">
+                <a16:creationId xmlns:a16="http://schemas.microsoft.com/office/drawing/2014/main" id="{A40267A2-CF7D-44BB-BEA6-7DA1FE95AAA7}"/>
+              </a:ext>
+            </a:extLst>
+          </p:cNvPr>
+          <p:cNvSpPr>
+            <a:spLocks xmlns:a="http://schemas.openxmlformats.org/drawingml/2006/main" noGrp="1"/>
+          </p:cNvSpPr>
+          <p:nvPr/>
+        </p:nvSpPr>
+        <p:spPr>
+          <a:xfrm xmlns:a="http://schemas.openxmlformats.org/drawingml/2006/main">
             <a:off x="815975" y="2129036"/>
             <a:ext cx="2025650" cy="1888133"/>
           </a:xfrm>
-          <a:prstGeom prst="roundRect">
+          <a:prstGeom xmlns:a="http://schemas.openxmlformats.org/drawingml/2006/main" prst="roundRect">
             <a:avLst>
               <a:gd name="adj" fmla="val 5213"/>
             </a:avLst>
           </a:prstGeom>
-          <a:solidFill>
+          <a:solidFill xmlns:a="http://schemas.openxmlformats.org/drawingml/2006/main">
             <a:srgbClr val="FCFCFB"/>
           </a:solidFill>
-          <a:ln w="6350">
+          <a:ln xmlns:a="http://schemas.openxmlformats.org/drawingml/2006/main" w="6350">
             <a:solidFill>
               <a:srgbClr val="D3DAE1"/>
             </a:solidFill>
@@ -37465,112 +37632,134 @@
       </p:sp>
       <p:sp>
         <p:nvSpPr>
-          <p:cNvPr id="7" name="Text 5"/>
-          <p:cNvSpPr/>
-          <p:nvPr/>
-        </p:nvSpPr>
-        <p:spPr>
-          <a:xfrm>
+          <p:cNvPr id="7" name="Text 5">
+            <a:extLst xmlns:a="http://schemas.openxmlformats.org/drawingml/2006/main">
+              <a:ext uri="{FF2B5EF4-FFF2-40B4-BE49-F238E27FC236}">
+                <a16:creationId xmlns:a16="http://schemas.microsoft.com/office/drawing/2014/main" id="{C33AA826-9B0E-4A49-9FA8-EB0CE41FB998}"/>
+              </a:ext>
+            </a:extLst>
+          </p:cNvPr>
+          <p:cNvSpPr>
+            <a:spLocks xmlns:a="http://schemas.openxmlformats.org/drawingml/2006/main" noGrp="1"/>
+          </p:cNvSpPr>
+          <p:nvPr/>
+        </p:nvSpPr>
+        <p:spPr>
+          <a:xfrm xmlns:a="http://schemas.openxmlformats.org/drawingml/2006/main">
             <a:off x="984250" y="2297311"/>
             <a:ext cx="1739900" cy="332680"/>
           </a:xfrm>
-          <a:prstGeom prst="rect">
-            <a:avLst/>
-          </a:prstGeom>
-          <a:noFill/>
-          <a:ln/>
-        </p:spPr>
-        <p:txBody>
-          <a:bodyPr wrap="square" lIns="0" tIns="0" rIns="0" bIns="0" rtlCol="0" anchor="t">
-            <a:normAutofit/>
-          </a:bodyPr>
-          <a:lstStyle/>
-          <a:p>
-            <a:pPr algn="l" indent="0" marL="0">
+          <a:prstGeom xmlns:a="http://schemas.openxmlformats.org/drawingml/2006/main" prst="rect">
+            <a:avLst/>
+          </a:prstGeom>
+          <a:noFill xmlns:a="http://schemas.openxmlformats.org/drawingml/2006/main"/>
+        </p:spPr>
+        <p:txBody>
+          <a:bodyPr xmlns:a="http://schemas.openxmlformats.org/drawingml/2006/main" wrap="square" lIns="0" tIns="0" rIns="0" bIns="0" anchor="t">
+            <a:normAutofit/>
+          </a:bodyPr>
+          <a:lstStyle xmlns:a="http://schemas.openxmlformats.org/drawingml/2006/main"/>
+          <a:p xmlns:a="http://schemas.openxmlformats.org/drawingml/2006/main">
+            <a:pPr marL="0" indent="0" algn="l">
               <a:lnSpc>
                 <a:spcPts val="2420"/>
               </a:lnSpc>
               <a:buNone/>
             </a:pPr>
             <a:r>
-              <a:rPr lang="en-US" sz="2200" dirty="0">
+              <a:rPr sz="2200">
                 <a:solidFill>
                   <a:srgbClr val="0E6E68"/>
                 </a:solidFill>
-                <a:latin typeface="IBM Plex Mono" pitchFamily="49" charset="0"/>
-                <a:ea typeface="IBM Plex Mono" pitchFamily="49" charset="-122"/>
-                <a:cs typeface="IBM Plex Mono" pitchFamily="49" charset="-120"/>
+                <a:latin typeface="IBM Plex Mono"/>
+                <a:ea typeface="IBM Plex Mono"/>
+                <a:cs typeface="IBM Plex Mono"/>
               </a:rPr>
               <a:t>01</a:t>
             </a:r>
-            <a:endParaRPr lang="en-US" sz="2200" dirty="0"/>
-          </a:p>
-        </p:txBody>
-      </p:sp>
-      <p:sp>
-        <p:nvSpPr>
-          <p:cNvPr id="8" name="Text 6"/>
-          <p:cNvSpPr/>
-          <p:nvPr/>
-        </p:nvSpPr>
-        <p:spPr>
-          <a:xfrm>
+            <a:endParaRPr sz="2200"/>
+          </a:p>
+        </p:txBody>
+      </p:sp>
+      <p:sp>
+        <p:nvSpPr>
+          <p:cNvPr id="8" name="Text 6">
+            <a:extLst xmlns:a="http://schemas.openxmlformats.org/drawingml/2006/main">
+              <a:ext uri="{FF2B5EF4-FFF2-40B4-BE49-F238E27FC236}">
+                <a16:creationId xmlns:a16="http://schemas.microsoft.com/office/drawing/2014/main" id="{98C813B7-1364-447E-B411-6018EE2E5E8F}"/>
+              </a:ext>
+            </a:extLst>
+          </p:cNvPr>
+          <p:cNvSpPr>
+            <a:spLocks xmlns:a="http://schemas.openxmlformats.org/drawingml/2006/main" noGrp="1"/>
+          </p:cNvSpPr>
+          <p:nvPr/>
+        </p:nvSpPr>
+        <p:spPr>
+          <a:xfrm xmlns:a="http://schemas.openxmlformats.org/drawingml/2006/main">
             <a:off x="984250" y="2693491"/>
             <a:ext cx="1739900" cy="718641"/>
           </a:xfrm>
-          <a:prstGeom prst="rect">
-            <a:avLst/>
-          </a:prstGeom>
-          <a:noFill/>
-          <a:ln/>
-        </p:spPr>
-        <p:txBody>
-          <a:bodyPr wrap="square" lIns="0" tIns="0" rIns="0" bIns="0" rtlCol="0" anchor="t">
-            <a:normAutofit/>
-          </a:bodyPr>
-          <a:lstStyle/>
-          <a:p>
-            <a:pPr algn="l" indent="0" marL="0">
+          <a:prstGeom xmlns:a="http://schemas.openxmlformats.org/drawingml/2006/main" prst="rect">
+            <a:avLst/>
+          </a:prstGeom>
+          <a:noFill xmlns:a="http://schemas.openxmlformats.org/drawingml/2006/main"/>
+        </p:spPr>
+        <p:txBody>
+          <a:bodyPr xmlns:a="http://schemas.openxmlformats.org/drawingml/2006/main" wrap="square" lIns="0" tIns="0" rIns="0" bIns="0" anchor="t">
+            <a:normAutofit/>
+          </a:bodyPr>
+          <a:lstStyle xmlns:a="http://schemas.openxmlformats.org/drawingml/2006/main"/>
+          <a:p xmlns:a="http://schemas.openxmlformats.org/drawingml/2006/main">
+            <a:pPr marL="0" indent="0" algn="l">
               <a:lnSpc>
                 <a:spcPts val="1820"/>
               </a:lnSpc>
               <a:buNone/>
             </a:pPr>
             <a:r>
-              <a:rPr lang="en-US" sz="1300" dirty="0">
+              <a:rPr sz="1300">
                 <a:solidFill>
                   <a:srgbClr val="13202D"/>
                 </a:solidFill>
-                <a:latin typeface="IBM Plex Sans" pitchFamily="34" charset="0"/>
-                <a:ea typeface="IBM Plex Sans" pitchFamily="34" charset="-122"/>
-                <a:cs typeface="IBM Plex Sans" pitchFamily="34" charset="-120"/>
+                <a:latin typeface="IBM Plex Sans"/>
+                <a:ea typeface="IBM Plex Sans"/>
+                <a:cs typeface="IBM Plex Sans"/>
               </a:rPr>
               <a:t>Написати User Story за једну ставку пројектног домена.</a:t>
             </a:r>
-            <a:endParaRPr lang="en-US" sz="1300" dirty="0"/>
-          </a:p>
-        </p:txBody>
-      </p:sp>
-      <p:sp>
-        <p:nvSpPr>
-          <p:cNvPr id="9" name="Shape 7"/>
-          <p:cNvSpPr/>
-          <p:nvPr/>
-        </p:nvSpPr>
-        <p:spPr>
-          <a:xfrm>
+            <a:endParaRPr sz="1300"/>
+          </a:p>
+        </p:txBody>
+      </p:sp>
+      <p:sp>
+        <p:nvSpPr>
+          <p:cNvPr id="9" name="Shape 7">
+            <a:extLst xmlns:a="http://schemas.openxmlformats.org/drawingml/2006/main">
+              <a:ext uri="{FF2B5EF4-FFF2-40B4-BE49-F238E27FC236}">
+                <a16:creationId xmlns:a16="http://schemas.microsoft.com/office/drawing/2014/main" id="{09E05520-082C-4C51-AB93-432181A71E42}"/>
+              </a:ext>
+            </a:extLst>
+          </p:cNvPr>
+          <p:cNvSpPr>
+            <a:spLocks xmlns:a="http://schemas.openxmlformats.org/drawingml/2006/main" noGrp="1"/>
+          </p:cNvSpPr>
+          <p:nvPr/>
+        </p:nvSpPr>
+        <p:spPr>
+          <a:xfrm xmlns:a="http://schemas.openxmlformats.org/drawingml/2006/main">
             <a:off x="2949575" y="2129036"/>
             <a:ext cx="2025650" cy="1888133"/>
           </a:xfrm>
-          <a:prstGeom prst="roundRect">
+          <a:prstGeom xmlns:a="http://schemas.openxmlformats.org/drawingml/2006/main" prst="roundRect">
             <a:avLst>
               <a:gd name="adj" fmla="val 5213"/>
             </a:avLst>
           </a:prstGeom>
-          <a:solidFill>
+          <a:solidFill xmlns:a="http://schemas.openxmlformats.org/drawingml/2006/main">
             <a:srgbClr val="FCFCFB"/>
           </a:solidFill>
-          <a:ln w="6350">
+          <a:ln xmlns:a="http://schemas.openxmlformats.org/drawingml/2006/main" w="6350">
             <a:solidFill>
               <a:srgbClr val="D3DAE1"/>
             </a:solidFill>
@@ -37580,112 +37769,134 @@
       </p:sp>
       <p:sp>
         <p:nvSpPr>
-          <p:cNvPr id="10" name="Text 8"/>
-          <p:cNvSpPr/>
-          <p:nvPr/>
-        </p:nvSpPr>
-        <p:spPr>
-          <a:xfrm>
+          <p:cNvPr id="10" name="Text 8">
+            <a:extLst xmlns:a="http://schemas.openxmlformats.org/drawingml/2006/main">
+              <a:ext uri="{FF2B5EF4-FFF2-40B4-BE49-F238E27FC236}">
+                <a16:creationId xmlns:a16="http://schemas.microsoft.com/office/drawing/2014/main" id="{ACDED543-BDEE-4092-8078-04ABAFE6F78F}"/>
+              </a:ext>
+            </a:extLst>
+          </p:cNvPr>
+          <p:cNvSpPr>
+            <a:spLocks xmlns:a="http://schemas.openxmlformats.org/drawingml/2006/main" noGrp="1"/>
+          </p:cNvSpPr>
+          <p:nvPr/>
+        </p:nvSpPr>
+        <p:spPr>
+          <a:xfrm xmlns:a="http://schemas.openxmlformats.org/drawingml/2006/main">
             <a:off x="3117850" y="2297311"/>
             <a:ext cx="1739900" cy="332680"/>
           </a:xfrm>
-          <a:prstGeom prst="rect">
-            <a:avLst/>
-          </a:prstGeom>
-          <a:noFill/>
-          <a:ln/>
-        </p:spPr>
-        <p:txBody>
-          <a:bodyPr wrap="square" lIns="0" tIns="0" rIns="0" bIns="0" rtlCol="0" anchor="t">
-            <a:normAutofit/>
-          </a:bodyPr>
-          <a:lstStyle/>
-          <a:p>
-            <a:pPr algn="l" indent="0" marL="0">
+          <a:prstGeom xmlns:a="http://schemas.openxmlformats.org/drawingml/2006/main" prst="rect">
+            <a:avLst/>
+          </a:prstGeom>
+          <a:noFill xmlns:a="http://schemas.openxmlformats.org/drawingml/2006/main"/>
+        </p:spPr>
+        <p:txBody>
+          <a:bodyPr xmlns:a="http://schemas.openxmlformats.org/drawingml/2006/main" wrap="square" lIns="0" tIns="0" rIns="0" bIns="0" anchor="t">
+            <a:normAutofit/>
+          </a:bodyPr>
+          <a:lstStyle xmlns:a="http://schemas.openxmlformats.org/drawingml/2006/main"/>
+          <a:p xmlns:a="http://schemas.openxmlformats.org/drawingml/2006/main">
+            <a:pPr marL="0" indent="0" algn="l">
               <a:lnSpc>
                 <a:spcPts val="2420"/>
               </a:lnSpc>
               <a:buNone/>
             </a:pPr>
             <a:r>
-              <a:rPr lang="en-US" sz="2200" dirty="0">
+              <a:rPr sz="2200">
                 <a:solidFill>
                   <a:srgbClr val="0E6E68"/>
                 </a:solidFill>
-                <a:latin typeface="IBM Plex Mono" pitchFamily="49" charset="0"/>
-                <a:ea typeface="IBM Plex Mono" pitchFamily="49" charset="-122"/>
-                <a:cs typeface="IBM Plex Mono" pitchFamily="49" charset="-120"/>
+                <a:latin typeface="IBM Plex Mono"/>
+                <a:ea typeface="IBM Plex Mono"/>
+                <a:cs typeface="IBM Plex Mono"/>
               </a:rPr>
               <a:t>02</a:t>
             </a:r>
-            <a:endParaRPr lang="en-US" sz="2200" dirty="0"/>
-          </a:p>
-        </p:txBody>
-      </p:sp>
-      <p:sp>
-        <p:nvSpPr>
-          <p:cNvPr id="11" name="Text 9"/>
-          <p:cNvSpPr/>
-          <p:nvPr/>
-        </p:nvSpPr>
-        <p:spPr>
-          <a:xfrm>
+            <a:endParaRPr sz="2200"/>
+          </a:p>
+        </p:txBody>
+      </p:sp>
+      <p:sp>
+        <p:nvSpPr>
+          <p:cNvPr id="11" name="Text 9">
+            <a:extLst xmlns:a="http://schemas.openxmlformats.org/drawingml/2006/main">
+              <a:ext uri="{FF2B5EF4-FFF2-40B4-BE49-F238E27FC236}">
+                <a16:creationId xmlns:a16="http://schemas.microsoft.com/office/drawing/2014/main" id="{6B80FC23-C39D-4907-B83D-6B9CB34E547D}"/>
+              </a:ext>
+            </a:extLst>
+          </p:cNvPr>
+          <p:cNvSpPr>
+            <a:spLocks xmlns:a="http://schemas.openxmlformats.org/drawingml/2006/main" noGrp="1"/>
+          </p:cNvSpPr>
+          <p:nvPr/>
+        </p:nvSpPr>
+        <p:spPr>
+          <a:xfrm xmlns:a="http://schemas.openxmlformats.org/drawingml/2006/main">
             <a:off x="3117850" y="2693491"/>
             <a:ext cx="1739900" cy="1180802"/>
           </a:xfrm>
-          <a:prstGeom prst="rect">
-            <a:avLst/>
-          </a:prstGeom>
-          <a:noFill/>
-          <a:ln/>
-        </p:spPr>
-        <p:txBody>
-          <a:bodyPr wrap="square" lIns="0" tIns="0" rIns="0" bIns="0" rtlCol="0" anchor="t">
-            <a:normAutofit/>
-          </a:bodyPr>
-          <a:lstStyle/>
-          <a:p>
-            <a:pPr algn="l" indent="0" marL="0">
+          <a:prstGeom xmlns:a="http://schemas.openxmlformats.org/drawingml/2006/main" prst="rect">
+            <a:avLst/>
+          </a:prstGeom>
+          <a:noFill xmlns:a="http://schemas.openxmlformats.org/drawingml/2006/main"/>
+        </p:spPr>
+        <p:txBody>
+          <a:bodyPr xmlns:a="http://schemas.openxmlformats.org/drawingml/2006/main" wrap="square" lIns="0" tIns="0" rIns="0" bIns="0" anchor="t">
+            <a:normAutofit/>
+          </a:bodyPr>
+          <a:lstStyle xmlns:a="http://schemas.openxmlformats.org/drawingml/2006/main"/>
+          <a:p xmlns:a="http://schemas.openxmlformats.org/drawingml/2006/main">
+            <a:pPr marL="0" indent="0" algn="l">
               <a:lnSpc>
                 <a:spcPts val="1820"/>
               </a:lnSpc>
               <a:buNone/>
             </a:pPr>
             <a:r>
-              <a:rPr lang="en-US" sz="1300" dirty="0">
+              <a:rPr sz="1300">
                 <a:solidFill>
                   <a:srgbClr val="13202D"/>
                 </a:solidFill>
-                <a:latin typeface="IBM Plex Sans" pitchFamily="34" charset="0"/>
-                <a:ea typeface="IBM Plex Sans" pitchFamily="34" charset="-122"/>
-                <a:cs typeface="IBM Plex Sans" pitchFamily="34" charset="-120"/>
+                <a:latin typeface="IBM Plex Sans"/>
+                <a:ea typeface="IBM Plex Sans"/>
+                <a:cs typeface="IBM Plex Sans"/>
               </a:rPr>
               <a:t>Додати успешне, негативне и граничне критеријуме прихватања.</a:t>
             </a:r>
-            <a:endParaRPr lang="en-US" sz="1300" dirty="0"/>
-          </a:p>
-        </p:txBody>
-      </p:sp>
-      <p:sp>
-        <p:nvSpPr>
-          <p:cNvPr id="12" name="Shape 10"/>
-          <p:cNvSpPr/>
-          <p:nvPr/>
-        </p:nvSpPr>
-        <p:spPr>
-          <a:xfrm>
+            <a:endParaRPr sz="1300"/>
+          </a:p>
+        </p:txBody>
+      </p:sp>
+      <p:sp>
+        <p:nvSpPr>
+          <p:cNvPr id="12" name="Shape 10">
+            <a:extLst xmlns:a="http://schemas.openxmlformats.org/drawingml/2006/main">
+              <a:ext uri="{FF2B5EF4-FFF2-40B4-BE49-F238E27FC236}">
+                <a16:creationId xmlns:a16="http://schemas.microsoft.com/office/drawing/2014/main" id="{CEACEEF9-2912-4C38-ABEC-201B005682DB}"/>
+              </a:ext>
+            </a:extLst>
+          </p:cNvPr>
+          <p:cNvSpPr>
+            <a:spLocks xmlns:a="http://schemas.openxmlformats.org/drawingml/2006/main" noGrp="1"/>
+          </p:cNvSpPr>
+          <p:nvPr/>
+        </p:nvSpPr>
+        <p:spPr>
+          <a:xfrm xmlns:a="http://schemas.openxmlformats.org/drawingml/2006/main">
             <a:off x="5083175" y="2129036"/>
             <a:ext cx="2025650" cy="1888133"/>
           </a:xfrm>
-          <a:prstGeom prst="roundRect">
+          <a:prstGeom xmlns:a="http://schemas.openxmlformats.org/drawingml/2006/main" prst="roundRect">
             <a:avLst>
               <a:gd name="adj" fmla="val 5213"/>
             </a:avLst>
           </a:prstGeom>
-          <a:solidFill>
+          <a:solidFill xmlns:a="http://schemas.openxmlformats.org/drawingml/2006/main">
             <a:srgbClr val="FCFCFB"/>
           </a:solidFill>
-          <a:ln w="6350">
+          <a:ln xmlns:a="http://schemas.openxmlformats.org/drawingml/2006/main" w="6350">
             <a:solidFill>
               <a:srgbClr val="D3DAE1"/>
             </a:solidFill>
@@ -37695,112 +37906,134 @@
       </p:sp>
       <p:sp>
         <p:nvSpPr>
-          <p:cNvPr id="13" name="Text 11"/>
-          <p:cNvSpPr/>
-          <p:nvPr/>
-        </p:nvSpPr>
-        <p:spPr>
-          <a:xfrm>
+          <p:cNvPr id="13" name="Text 11">
+            <a:extLst xmlns:a="http://schemas.openxmlformats.org/drawingml/2006/main">
+              <a:ext uri="{FF2B5EF4-FFF2-40B4-BE49-F238E27FC236}">
+                <a16:creationId xmlns:a16="http://schemas.microsoft.com/office/drawing/2014/main" id="{DD773EAE-E940-4F58-8AC2-601960CF3A9F}"/>
+              </a:ext>
+            </a:extLst>
+          </p:cNvPr>
+          <p:cNvSpPr>
+            <a:spLocks xmlns:a="http://schemas.openxmlformats.org/drawingml/2006/main" noGrp="1"/>
+          </p:cNvSpPr>
+          <p:nvPr/>
+        </p:nvSpPr>
+        <p:spPr>
+          <a:xfrm xmlns:a="http://schemas.openxmlformats.org/drawingml/2006/main">
             <a:off x="5251450" y="2297311"/>
             <a:ext cx="1739900" cy="332680"/>
           </a:xfrm>
-          <a:prstGeom prst="rect">
-            <a:avLst/>
-          </a:prstGeom>
-          <a:noFill/>
-          <a:ln/>
-        </p:spPr>
-        <p:txBody>
-          <a:bodyPr wrap="square" lIns="0" tIns="0" rIns="0" bIns="0" rtlCol="0" anchor="t">
-            <a:normAutofit/>
-          </a:bodyPr>
-          <a:lstStyle/>
-          <a:p>
-            <a:pPr algn="l" indent="0" marL="0">
+          <a:prstGeom xmlns:a="http://schemas.openxmlformats.org/drawingml/2006/main" prst="rect">
+            <a:avLst/>
+          </a:prstGeom>
+          <a:noFill xmlns:a="http://schemas.openxmlformats.org/drawingml/2006/main"/>
+        </p:spPr>
+        <p:txBody>
+          <a:bodyPr xmlns:a="http://schemas.openxmlformats.org/drawingml/2006/main" wrap="square" lIns="0" tIns="0" rIns="0" bIns="0" anchor="t">
+            <a:normAutofit/>
+          </a:bodyPr>
+          <a:lstStyle xmlns:a="http://schemas.openxmlformats.org/drawingml/2006/main"/>
+          <a:p xmlns:a="http://schemas.openxmlformats.org/drawingml/2006/main">
+            <a:pPr marL="0" indent="0" algn="l">
               <a:lnSpc>
                 <a:spcPts val="2420"/>
               </a:lnSpc>
               <a:buNone/>
             </a:pPr>
             <a:r>
-              <a:rPr lang="en-US" sz="2200" dirty="0">
+              <a:rPr sz="2200">
                 <a:solidFill>
                   <a:srgbClr val="0E6E68"/>
                 </a:solidFill>
-                <a:latin typeface="IBM Plex Mono" pitchFamily="49" charset="0"/>
-                <a:ea typeface="IBM Plex Mono" pitchFamily="49" charset="-122"/>
-                <a:cs typeface="IBM Plex Mono" pitchFamily="49" charset="-120"/>
+                <a:latin typeface="IBM Plex Mono"/>
+                <a:ea typeface="IBM Plex Mono"/>
+                <a:cs typeface="IBM Plex Mono"/>
               </a:rPr>
               <a:t>03</a:t>
             </a:r>
-            <a:endParaRPr lang="en-US" sz="2200" dirty="0"/>
-          </a:p>
-        </p:txBody>
-      </p:sp>
-      <p:sp>
-        <p:nvSpPr>
-          <p:cNvPr id="14" name="Text 12"/>
-          <p:cNvSpPr/>
-          <p:nvPr/>
-        </p:nvSpPr>
-        <p:spPr>
-          <a:xfrm>
+            <a:endParaRPr sz="2200"/>
+          </a:p>
+        </p:txBody>
+      </p:sp>
+      <p:sp>
+        <p:nvSpPr>
+          <p:cNvPr id="14" name="Text 12">
+            <a:extLst xmlns:a="http://schemas.openxmlformats.org/drawingml/2006/main">
+              <a:ext uri="{FF2B5EF4-FFF2-40B4-BE49-F238E27FC236}">
+                <a16:creationId xmlns:a16="http://schemas.microsoft.com/office/drawing/2014/main" id="{A8E09FE3-6BD4-4BA5-B98C-7580B5A50791}"/>
+              </a:ext>
+            </a:extLst>
+          </p:cNvPr>
+          <p:cNvSpPr>
+            <a:spLocks xmlns:a="http://schemas.openxmlformats.org/drawingml/2006/main" noGrp="1"/>
+          </p:cNvSpPr>
+          <p:nvPr/>
+        </p:nvSpPr>
+        <p:spPr>
+          <a:xfrm xmlns:a="http://schemas.openxmlformats.org/drawingml/2006/main">
             <a:off x="5251450" y="2693491"/>
             <a:ext cx="1739900" cy="718641"/>
           </a:xfrm>
-          <a:prstGeom prst="rect">
-            <a:avLst/>
-          </a:prstGeom>
-          <a:noFill/>
-          <a:ln/>
-        </p:spPr>
-        <p:txBody>
-          <a:bodyPr wrap="square" lIns="0" tIns="0" rIns="0" bIns="0" rtlCol="0" anchor="t">
-            <a:normAutofit/>
-          </a:bodyPr>
-          <a:lstStyle/>
-          <a:p>
-            <a:pPr algn="l" indent="0" marL="0">
+          <a:prstGeom xmlns:a="http://schemas.openxmlformats.org/drawingml/2006/main" prst="rect">
+            <a:avLst/>
+          </a:prstGeom>
+          <a:noFill xmlns:a="http://schemas.openxmlformats.org/drawingml/2006/main"/>
+        </p:spPr>
+        <p:txBody>
+          <a:bodyPr xmlns:a="http://schemas.openxmlformats.org/drawingml/2006/main" wrap="square" lIns="0" tIns="0" rIns="0" bIns="0" anchor="t">
+            <a:normAutofit/>
+          </a:bodyPr>
+          <a:lstStyle xmlns:a="http://schemas.openxmlformats.org/drawingml/2006/main"/>
+          <a:p xmlns:a="http://schemas.openxmlformats.org/drawingml/2006/main">
+            <a:pPr marL="0" indent="0" algn="l">
               <a:lnSpc>
                 <a:spcPts val="1820"/>
               </a:lnSpc>
               <a:buNone/>
             </a:pPr>
             <a:r>
-              <a:rPr lang="en-US" sz="1300" dirty="0">
+              <a:rPr sz="1300">
                 <a:solidFill>
                   <a:srgbClr val="13202D"/>
                 </a:solidFill>
-                <a:latin typeface="IBM Plex Sans" pitchFamily="34" charset="0"/>
-                <a:ea typeface="IBM Plex Sans" pitchFamily="34" charset="-122"/>
-                <a:cs typeface="IBM Plex Sans" pitchFamily="34" charset="-120"/>
+                <a:latin typeface="IBM Plex Sans"/>
+                <a:ea typeface="IBM Plex Sans"/>
+                <a:cs typeface="IBM Plex Sans"/>
               </a:rPr>
               <a:t>Увести ставку у Tapiz ток и радити преко feature гране.</a:t>
             </a:r>
-            <a:endParaRPr lang="en-US" sz="1300" dirty="0"/>
-          </a:p>
-        </p:txBody>
-      </p:sp>
-      <p:sp>
-        <p:nvSpPr>
-          <p:cNvPr id="15" name="Shape 13"/>
-          <p:cNvSpPr/>
-          <p:nvPr/>
-        </p:nvSpPr>
-        <p:spPr>
-          <a:xfrm>
+            <a:endParaRPr sz="1300"/>
+          </a:p>
+        </p:txBody>
+      </p:sp>
+      <p:sp>
+        <p:nvSpPr>
+          <p:cNvPr id="15" name="Shape 13">
+            <a:extLst xmlns:a="http://schemas.openxmlformats.org/drawingml/2006/main">
+              <a:ext uri="{FF2B5EF4-FFF2-40B4-BE49-F238E27FC236}">
+                <a16:creationId xmlns:a16="http://schemas.microsoft.com/office/drawing/2014/main" id="{DA04F0D9-6B0C-4029-B138-0AD95398BAF4}"/>
+              </a:ext>
+            </a:extLst>
+          </p:cNvPr>
+          <p:cNvSpPr>
+            <a:spLocks xmlns:a="http://schemas.openxmlformats.org/drawingml/2006/main" noGrp="1"/>
+          </p:cNvSpPr>
+          <p:nvPr/>
+        </p:nvSpPr>
+        <p:spPr>
+          <a:xfrm xmlns:a="http://schemas.openxmlformats.org/drawingml/2006/main">
             <a:off x="7216775" y="2129036"/>
             <a:ext cx="2025650" cy="1888133"/>
           </a:xfrm>
-          <a:prstGeom prst="roundRect">
+          <a:prstGeom xmlns:a="http://schemas.openxmlformats.org/drawingml/2006/main" prst="roundRect">
             <a:avLst>
               <a:gd name="adj" fmla="val 5213"/>
             </a:avLst>
           </a:prstGeom>
-          <a:solidFill>
+          <a:solidFill xmlns:a="http://schemas.openxmlformats.org/drawingml/2006/main">
             <a:srgbClr val="FCFCFB"/>
           </a:solidFill>
-          <a:ln w="6350">
+          <a:ln xmlns:a="http://schemas.openxmlformats.org/drawingml/2006/main" w="6350">
             <a:solidFill>
               <a:srgbClr val="D3DAE1"/>
             </a:solidFill>
@@ -37810,112 +38043,134 @@
       </p:sp>
       <p:sp>
         <p:nvSpPr>
-          <p:cNvPr id="16" name="Text 14"/>
-          <p:cNvSpPr/>
-          <p:nvPr/>
-        </p:nvSpPr>
-        <p:spPr>
-          <a:xfrm>
+          <p:cNvPr id="16" name="Text 14">
+            <a:extLst xmlns:a="http://schemas.openxmlformats.org/drawingml/2006/main">
+              <a:ext uri="{FF2B5EF4-FFF2-40B4-BE49-F238E27FC236}">
+                <a16:creationId xmlns:a16="http://schemas.microsoft.com/office/drawing/2014/main" id="{BA4FA61E-CCD4-48D1-8465-EE248FBA6A79}"/>
+              </a:ext>
+            </a:extLst>
+          </p:cNvPr>
+          <p:cNvSpPr>
+            <a:spLocks xmlns:a="http://schemas.openxmlformats.org/drawingml/2006/main" noGrp="1"/>
+          </p:cNvSpPr>
+          <p:nvPr/>
+        </p:nvSpPr>
+        <p:spPr>
+          <a:xfrm xmlns:a="http://schemas.openxmlformats.org/drawingml/2006/main">
             <a:off x="7385050" y="2297311"/>
             <a:ext cx="1739900" cy="332680"/>
           </a:xfrm>
-          <a:prstGeom prst="rect">
-            <a:avLst/>
-          </a:prstGeom>
-          <a:noFill/>
-          <a:ln/>
-        </p:spPr>
-        <p:txBody>
-          <a:bodyPr wrap="square" lIns="0" tIns="0" rIns="0" bIns="0" rtlCol="0" anchor="t">
-            <a:normAutofit/>
-          </a:bodyPr>
-          <a:lstStyle/>
-          <a:p>
-            <a:pPr algn="l" indent="0" marL="0">
+          <a:prstGeom xmlns:a="http://schemas.openxmlformats.org/drawingml/2006/main" prst="rect">
+            <a:avLst/>
+          </a:prstGeom>
+          <a:noFill xmlns:a="http://schemas.openxmlformats.org/drawingml/2006/main"/>
+        </p:spPr>
+        <p:txBody>
+          <a:bodyPr xmlns:a="http://schemas.openxmlformats.org/drawingml/2006/main" wrap="square" lIns="0" tIns="0" rIns="0" bIns="0" anchor="t">
+            <a:normAutofit/>
+          </a:bodyPr>
+          <a:lstStyle xmlns:a="http://schemas.openxmlformats.org/drawingml/2006/main"/>
+          <a:p xmlns:a="http://schemas.openxmlformats.org/drawingml/2006/main">
+            <a:pPr marL="0" indent="0" algn="l">
               <a:lnSpc>
                 <a:spcPts val="2420"/>
               </a:lnSpc>
               <a:buNone/>
             </a:pPr>
             <a:r>
-              <a:rPr lang="en-US" sz="2200" dirty="0">
+              <a:rPr sz="2200">
                 <a:solidFill>
                   <a:srgbClr val="0E6E68"/>
                 </a:solidFill>
-                <a:latin typeface="IBM Plex Mono" pitchFamily="49" charset="0"/>
-                <a:ea typeface="IBM Plex Mono" pitchFamily="49" charset="-122"/>
-                <a:cs typeface="IBM Plex Mono" pitchFamily="49" charset="-120"/>
+                <a:latin typeface="IBM Plex Mono"/>
+                <a:ea typeface="IBM Plex Mono"/>
+                <a:cs typeface="IBM Plex Mono"/>
               </a:rPr>
               <a:t>04</a:t>
             </a:r>
-            <a:endParaRPr lang="en-US" sz="2200" dirty="0"/>
-          </a:p>
-        </p:txBody>
-      </p:sp>
-      <p:sp>
-        <p:nvSpPr>
-          <p:cNvPr id="17" name="Text 15"/>
-          <p:cNvSpPr/>
-          <p:nvPr/>
-        </p:nvSpPr>
-        <p:spPr>
-          <a:xfrm>
+            <a:endParaRPr sz="2200"/>
+          </a:p>
+        </p:txBody>
+      </p:sp>
+      <p:sp>
+        <p:nvSpPr>
+          <p:cNvPr id="17" name="Text 15">
+            <a:extLst xmlns:a="http://schemas.openxmlformats.org/drawingml/2006/main">
+              <a:ext uri="{FF2B5EF4-FFF2-40B4-BE49-F238E27FC236}">
+                <a16:creationId xmlns:a16="http://schemas.microsoft.com/office/drawing/2014/main" id="{A15F2CE4-46E1-4D88-9893-54E173A5706D}"/>
+              </a:ext>
+            </a:extLst>
+          </p:cNvPr>
+          <p:cNvSpPr>
+            <a:spLocks xmlns:a="http://schemas.openxmlformats.org/drawingml/2006/main" noGrp="1"/>
+          </p:cNvSpPr>
+          <p:nvPr/>
+        </p:nvSpPr>
+        <p:spPr>
+          <a:xfrm xmlns:a="http://schemas.openxmlformats.org/drawingml/2006/main">
             <a:off x="7385050" y="2693491"/>
             <a:ext cx="1739900" cy="718641"/>
           </a:xfrm>
-          <a:prstGeom prst="rect">
-            <a:avLst/>
-          </a:prstGeom>
-          <a:noFill/>
-          <a:ln/>
-        </p:spPr>
-        <p:txBody>
-          <a:bodyPr wrap="square" lIns="0" tIns="0" rIns="0" bIns="0" rtlCol="0" anchor="t">
-            <a:normAutofit/>
-          </a:bodyPr>
-          <a:lstStyle/>
-          <a:p>
-            <a:pPr algn="l" indent="0" marL="0">
+          <a:prstGeom xmlns:a="http://schemas.openxmlformats.org/drawingml/2006/main" prst="rect">
+            <a:avLst/>
+          </a:prstGeom>
+          <a:noFill xmlns:a="http://schemas.openxmlformats.org/drawingml/2006/main"/>
+        </p:spPr>
+        <p:txBody>
+          <a:bodyPr xmlns:a="http://schemas.openxmlformats.org/drawingml/2006/main" wrap="square" lIns="0" tIns="0" rIns="0" bIns="0" anchor="t">
+            <a:normAutofit/>
+          </a:bodyPr>
+          <a:lstStyle xmlns:a="http://schemas.openxmlformats.org/drawingml/2006/main"/>
+          <a:p xmlns:a="http://schemas.openxmlformats.org/drawingml/2006/main">
+            <a:pPr marL="0" indent="0" algn="l">
               <a:lnSpc>
                 <a:spcPts val="1820"/>
               </a:lnSpc>
               <a:buNone/>
             </a:pPr>
             <a:r>
-              <a:rPr lang="en-US" sz="1300" dirty="0">
+              <a:rPr sz="1300">
                 <a:solidFill>
                   <a:srgbClr val="13202D"/>
                 </a:solidFill>
-                <a:latin typeface="IBM Plex Sans" pitchFamily="34" charset="0"/>
-                <a:ea typeface="IBM Plex Sans" pitchFamily="34" charset="-122"/>
-                <a:cs typeface="IBM Plex Sans" pitchFamily="34" charset="-120"/>
+                <a:latin typeface="IBM Plex Sans"/>
+                <a:ea typeface="IBM Plex Sans"/>
+                <a:cs typeface="IBM Plex Sans"/>
               </a:rPr>
               <a:t>Отворити Pull Request са доказом провере.</a:t>
             </a:r>
-            <a:endParaRPr lang="en-US" sz="1300" dirty="0"/>
-          </a:p>
-        </p:txBody>
-      </p:sp>
-      <p:sp>
-        <p:nvSpPr>
-          <p:cNvPr id="18" name="Shape 16"/>
-          <p:cNvSpPr/>
-          <p:nvPr/>
-        </p:nvSpPr>
-        <p:spPr>
-          <a:xfrm>
+            <a:endParaRPr sz="1300"/>
+          </a:p>
+        </p:txBody>
+      </p:sp>
+      <p:sp>
+        <p:nvSpPr>
+          <p:cNvPr id="18" name="Shape 16">
+            <a:extLst xmlns:a="http://schemas.openxmlformats.org/drawingml/2006/main">
+              <a:ext uri="{FF2B5EF4-FFF2-40B4-BE49-F238E27FC236}">
+                <a16:creationId xmlns:a16="http://schemas.microsoft.com/office/drawing/2014/main" id="{4789AB29-031C-471D-84BD-9AB40FC12E58}"/>
+              </a:ext>
+            </a:extLst>
+          </p:cNvPr>
+          <p:cNvSpPr>
+            <a:spLocks xmlns:a="http://schemas.openxmlformats.org/drawingml/2006/main" noGrp="1"/>
+          </p:cNvSpPr>
+          <p:nvPr/>
+        </p:nvSpPr>
+        <p:spPr>
+          <a:xfrm xmlns:a="http://schemas.openxmlformats.org/drawingml/2006/main">
             <a:off x="9350375" y="2129036"/>
             <a:ext cx="2025650" cy="1888133"/>
           </a:xfrm>
-          <a:prstGeom prst="roundRect">
+          <a:prstGeom xmlns:a="http://schemas.openxmlformats.org/drawingml/2006/main" prst="roundRect">
             <a:avLst>
               <a:gd name="adj" fmla="val 5213"/>
             </a:avLst>
           </a:prstGeom>
-          <a:solidFill>
+          <a:solidFill xmlns:a="http://schemas.openxmlformats.org/drawingml/2006/main">
             <a:srgbClr val="FCFCFB"/>
           </a:solidFill>
-          <a:ln w="6350">
+          <a:ln xmlns:a="http://schemas.openxmlformats.org/drawingml/2006/main" w="6350">
             <a:solidFill>
               <a:srgbClr val="D3DAE1"/>
             </a:solidFill>
@@ -37925,197 +38180,239 @@
       </p:sp>
       <p:sp>
         <p:nvSpPr>
-          <p:cNvPr id="19" name="Text 17"/>
-          <p:cNvSpPr/>
-          <p:nvPr/>
-        </p:nvSpPr>
-        <p:spPr>
-          <a:xfrm>
+          <p:cNvPr id="19" name="Text 17">
+            <a:extLst xmlns:a="http://schemas.openxmlformats.org/drawingml/2006/main">
+              <a:ext uri="{FF2B5EF4-FFF2-40B4-BE49-F238E27FC236}">
+                <a16:creationId xmlns:a16="http://schemas.microsoft.com/office/drawing/2014/main" id="{CC727334-BA1A-476A-AB1C-F47A1CB31286}"/>
+              </a:ext>
+            </a:extLst>
+          </p:cNvPr>
+          <p:cNvSpPr>
+            <a:spLocks xmlns:a="http://schemas.openxmlformats.org/drawingml/2006/main" noGrp="1"/>
+          </p:cNvSpPr>
+          <p:nvPr/>
+        </p:nvSpPr>
+        <p:spPr>
+          <a:xfrm xmlns:a="http://schemas.openxmlformats.org/drawingml/2006/main">
             <a:off x="9518650" y="2297311"/>
             <a:ext cx="1739900" cy="332680"/>
           </a:xfrm>
-          <a:prstGeom prst="rect">
-            <a:avLst/>
-          </a:prstGeom>
-          <a:noFill/>
-          <a:ln/>
-        </p:spPr>
-        <p:txBody>
-          <a:bodyPr wrap="square" lIns="0" tIns="0" rIns="0" bIns="0" rtlCol="0" anchor="t">
-            <a:normAutofit/>
-          </a:bodyPr>
-          <a:lstStyle/>
-          <a:p>
-            <a:pPr algn="l" indent="0" marL="0">
+          <a:prstGeom xmlns:a="http://schemas.openxmlformats.org/drawingml/2006/main" prst="rect">
+            <a:avLst/>
+          </a:prstGeom>
+          <a:noFill xmlns:a="http://schemas.openxmlformats.org/drawingml/2006/main"/>
+        </p:spPr>
+        <p:txBody>
+          <a:bodyPr xmlns:a="http://schemas.openxmlformats.org/drawingml/2006/main" wrap="square" lIns="0" tIns="0" rIns="0" bIns="0" anchor="t">
+            <a:normAutofit/>
+          </a:bodyPr>
+          <a:lstStyle xmlns:a="http://schemas.openxmlformats.org/drawingml/2006/main"/>
+          <a:p xmlns:a="http://schemas.openxmlformats.org/drawingml/2006/main">
+            <a:pPr marL="0" indent="0" algn="l">
               <a:lnSpc>
                 <a:spcPts val="2420"/>
               </a:lnSpc>
               <a:buNone/>
             </a:pPr>
             <a:r>
-              <a:rPr lang="en-US" sz="2200" dirty="0">
+              <a:rPr sz="2200">
                 <a:solidFill>
                   <a:srgbClr val="A8520A"/>
                 </a:solidFill>
-                <a:latin typeface="IBM Plex Mono" pitchFamily="49" charset="0"/>
-                <a:ea typeface="IBM Plex Mono" pitchFamily="49" charset="-122"/>
-                <a:cs typeface="IBM Plex Mono" pitchFamily="49" charset="-120"/>
+                <a:latin typeface="IBM Plex Mono"/>
+                <a:ea typeface="IBM Plex Mono"/>
+                <a:cs typeface="IBM Plex Mono"/>
               </a:rPr>
               <a:t>05</a:t>
             </a:r>
-            <a:endParaRPr lang="en-US" sz="2200" dirty="0"/>
-          </a:p>
-        </p:txBody>
-      </p:sp>
-      <p:sp>
-        <p:nvSpPr>
-          <p:cNvPr id="20" name="Text 18"/>
-          <p:cNvSpPr/>
-          <p:nvPr/>
-        </p:nvSpPr>
-        <p:spPr>
-          <a:xfrm>
+            <a:endParaRPr sz="2200"/>
+          </a:p>
+        </p:txBody>
+      </p:sp>
+      <p:sp>
+        <p:nvSpPr>
+          <p:cNvPr id="20" name="Text 18">
+            <a:extLst xmlns:a="http://schemas.openxmlformats.org/drawingml/2006/main">
+              <a:ext uri="{FF2B5EF4-FFF2-40B4-BE49-F238E27FC236}">
+                <a16:creationId xmlns:a16="http://schemas.microsoft.com/office/drawing/2014/main" id="{67CC7E58-6F09-4741-9BFF-C2942644A734}"/>
+              </a:ext>
+            </a:extLst>
+          </p:cNvPr>
+          <p:cNvSpPr>
+            <a:spLocks xmlns:a="http://schemas.openxmlformats.org/drawingml/2006/main" noGrp="1"/>
+          </p:cNvSpPr>
+          <p:nvPr/>
+        </p:nvSpPr>
+        <p:spPr>
+          <a:xfrm xmlns:a="http://schemas.openxmlformats.org/drawingml/2006/main">
             <a:off x="9518650" y="2693491"/>
             <a:ext cx="1739900" cy="949722"/>
           </a:xfrm>
-          <a:prstGeom prst="rect">
-            <a:avLst/>
-          </a:prstGeom>
-          <a:noFill/>
-          <a:ln/>
-        </p:spPr>
-        <p:txBody>
-          <a:bodyPr wrap="square" lIns="0" tIns="0" rIns="0" bIns="0" rtlCol="0" anchor="t">
-            <a:normAutofit/>
-          </a:bodyPr>
-          <a:lstStyle/>
-          <a:p>
-            <a:pPr algn="l" indent="0" marL="0">
+          <a:prstGeom xmlns:a="http://schemas.openxmlformats.org/drawingml/2006/main" prst="rect">
+            <a:avLst/>
+          </a:prstGeom>
+          <a:noFill xmlns:a="http://schemas.openxmlformats.org/drawingml/2006/main"/>
+        </p:spPr>
+        <p:txBody>
+          <a:bodyPr xmlns:a="http://schemas.openxmlformats.org/drawingml/2006/main" wrap="square" lIns="0" tIns="0" rIns="0" bIns="0" anchor="t">
+            <a:normAutofit/>
+          </a:bodyPr>
+          <a:lstStyle xmlns:a="http://schemas.openxmlformats.org/drawingml/2006/main"/>
+          <a:p xmlns:a="http://schemas.openxmlformats.org/drawingml/2006/main">
+            <a:pPr marL="0" indent="0" algn="l">
               <a:lnSpc>
                 <a:spcPts val="1820"/>
               </a:lnSpc>
               <a:buNone/>
             </a:pPr>
             <a:r>
-              <a:rPr lang="en-US" sz="1300" dirty="0">
+              <a:rPr sz="1300">
                 <a:solidFill>
                   <a:srgbClr val="13202D"/>
                 </a:solidFill>
-                <a:latin typeface="IBM Plex Sans" pitchFamily="34" charset="0"/>
-                <a:ea typeface="IBM Plex Sans" pitchFamily="34" charset="-122"/>
-                <a:cs typeface="IBM Plex Sans" pitchFamily="34" charset="-120"/>
+                <a:latin typeface="IBM Plex Sans"/>
+                <a:ea typeface="IBM Plex Sans"/>
+                <a:cs typeface="IBM Plex Sans"/>
               </a:rPr>
               <a:t>Објаснити цео пут од захтева до интегрисане промене.</a:t>
             </a:r>
-            <a:endParaRPr lang="en-US" sz="1300" dirty="0"/>
-          </a:p>
-        </p:txBody>
-      </p:sp>
-      <p:sp>
-        <p:nvSpPr>
-          <p:cNvPr id="21" name="Shape 19"/>
-          <p:cNvSpPr/>
-          <p:nvPr/>
-        </p:nvSpPr>
-        <p:spPr>
-          <a:xfrm>
+            <a:endParaRPr sz="1300"/>
+          </a:p>
+        </p:txBody>
+      </p:sp>
+      <p:sp>
+        <p:nvSpPr>
+          <p:cNvPr id="21" name="Shape 19">
+            <a:extLst xmlns:a="http://schemas.openxmlformats.org/drawingml/2006/main">
+              <a:ext uri="{FF2B5EF4-FFF2-40B4-BE49-F238E27FC236}">
+                <a16:creationId xmlns:a16="http://schemas.microsoft.com/office/drawing/2014/main" id="{333F27A2-67E7-41A9-8464-7023E7496CE1}"/>
+              </a:ext>
+            </a:extLst>
+          </p:cNvPr>
+          <p:cNvSpPr>
+            <a:spLocks xmlns:a="http://schemas.openxmlformats.org/drawingml/2006/main" noGrp="1"/>
+          </p:cNvSpPr>
+          <p:nvPr/>
+        </p:nvSpPr>
+        <p:spPr>
+          <a:xfrm xmlns:a="http://schemas.openxmlformats.org/drawingml/2006/main">
             <a:off x="812800" y="4248944"/>
             <a:ext cx="10566400" cy="451445"/>
           </a:xfrm>
-          <a:prstGeom prst="roundRect">
+          <a:prstGeom xmlns:a="http://schemas.openxmlformats.org/drawingml/2006/main" prst="roundRect">
             <a:avLst>
               <a:gd name="adj" fmla="val 19692"/>
             </a:avLst>
           </a:prstGeom>
-          <a:solidFill>
+          <a:solidFill xmlns:a="http://schemas.openxmlformats.org/drawingml/2006/main">
             <a:srgbClr val="E2EBE9"/>
           </a:solidFill>
-          <a:ln/>
         </p:spPr>
       </p:sp>
       <p:pic>
         <p:nvPicPr>
-          <p:cNvPr id="22" name="Image 0" descr="Clock">    </p:cNvPr>
+          <p:cNvPr id="22" name="Image 0">
+            <a:extLst xmlns:a="http://schemas.openxmlformats.org/drawingml/2006/main">
+              <a:ext uri="{FF2B5EF4-FFF2-40B4-BE49-F238E27FC236}">
+                <a16:creationId xmlns:a16="http://schemas.microsoft.com/office/drawing/2014/main" id="{A0A2B0A3-0107-485C-B3F4-08B29459F310}"/>
+              </a:ext>
+            </a:extLst>
+          </p:cNvPr>
           <p:cNvPicPr>
-            <a:picLocks noChangeAspect="1"/>
+            <a:picLocks xmlns:a="http://schemas.openxmlformats.org/drawingml/2006/main" noChangeAspect="1"/>
           </p:cNvPicPr>
           <p:nvPr/>
         </p:nvPicPr>
         <p:blipFill>
-          <a:blip r:embed="rId1"/>
-          <a:srcRect l="0" r="0" t="0" b="0"/>
-          <a:stretch/>
+          <a:blip xmlns:r="http://schemas.openxmlformats.org/officeDocument/2006/relationships" xmlns:a="http://schemas.openxmlformats.org/drawingml/2006/main" r:embed="R588df93b5c864273"/>
+          <a:srcRect xmlns:a="http://schemas.openxmlformats.org/drawingml/2006/main" l="0" t="0" r="0" b="0"/>
+          <a:stretch xmlns:a="http://schemas.openxmlformats.org/drawingml/2006/main"/>
         </p:blipFill>
         <p:spPr>
-          <a:xfrm>
+          <a:xfrm xmlns:a="http://schemas.openxmlformats.org/drawingml/2006/main">
             <a:off x="990600" y="4373066"/>
             <a:ext cx="203200" cy="203200"/>
           </a:xfrm>
-          <a:prstGeom prst="rect">
+          <a:prstGeom xmlns:a="http://schemas.openxmlformats.org/drawingml/2006/main" prst="rect">
             <a:avLst/>
           </a:prstGeom>
         </p:spPr>
       </p:pic>
       <p:sp>
         <p:nvSpPr>
-          <p:cNvPr id="23" name="Text 20"/>
-          <p:cNvSpPr/>
-          <p:nvPr/>
-        </p:nvSpPr>
-        <p:spPr>
-          <a:xfrm>
+          <p:cNvPr id="23" name="Text 20">
+            <a:extLst xmlns:a="http://schemas.openxmlformats.org/drawingml/2006/main">
+              <a:ext uri="{FF2B5EF4-FFF2-40B4-BE49-F238E27FC236}">
+                <a16:creationId xmlns:a16="http://schemas.microsoft.com/office/drawing/2014/main" id="{50B4C2DF-B3A1-4E34-B2CE-7595CE269E10}"/>
+              </a:ext>
+            </a:extLst>
+          </p:cNvPr>
+          <p:cNvSpPr>
+            <a:spLocks xmlns:a="http://schemas.openxmlformats.org/drawingml/2006/main" noGrp="1"/>
+          </p:cNvSpPr>
+          <p:nvPr/>
+        </p:nvSpPr>
+        <p:spPr>
+          <a:xfrm xmlns:a="http://schemas.openxmlformats.org/drawingml/2006/main">
             <a:off x="1320800" y="4363244"/>
             <a:ext cx="10177018" cy="248245"/>
           </a:xfrm>
-          <a:prstGeom prst="rect">
-            <a:avLst/>
-          </a:prstGeom>
-          <a:noFill/>
-          <a:ln/>
-        </p:spPr>
-        <p:txBody>
-          <a:bodyPr wrap="square" lIns="0" tIns="0" rIns="0" bIns="0" rtlCol="0" anchor="t">
-            <a:normAutofit/>
-          </a:bodyPr>
-          <a:lstStyle/>
-          <a:p>
-            <a:pPr algn="l" indent="0" marL="0">
+          <a:prstGeom xmlns:a="http://schemas.openxmlformats.org/drawingml/2006/main" prst="rect">
+            <a:avLst/>
+          </a:prstGeom>
+          <a:noFill xmlns:a="http://schemas.openxmlformats.org/drawingml/2006/main"/>
+        </p:spPr>
+        <p:txBody>
+          <a:bodyPr xmlns:a="http://schemas.openxmlformats.org/drawingml/2006/main" wrap="square" lIns="0" tIns="0" rIns="0" bIns="0" anchor="t">
+            <a:normAutofit fontScale="100000"/>
+          </a:bodyPr>
+          <a:lstStyle xmlns:a="http://schemas.openxmlformats.org/drawingml/2006/main"/>
+          <a:p xmlns:a="http://schemas.openxmlformats.org/drawingml/2006/main">
+            <a:pPr marL="0" indent="0" algn="l">
               <a:lnSpc>
                 <a:spcPts val="1755"/>
               </a:lnSpc>
               <a:buNone/>
             </a:pPr>
             <a:r>
-              <a:rPr lang="en-US" sz="1300" dirty="0">
+              <a:rPr sz="1300">
                 <a:solidFill>
                   <a:srgbClr val="13202D"/>
                 </a:solidFill>
-                <a:latin typeface="IBM Plex Sans" pitchFamily="34" charset="0"/>
-                <a:ea typeface="IBM Plex Sans" pitchFamily="34" charset="-122"/>
-                <a:cs typeface="IBM Plex Sans" pitchFamily="34" charset="-120"/>
-              </a:rPr>
-              <a:t>Ово је основа за контролну тачку КТ1, после Вежбе 2.</a:t>
-            </a:r>
-            <a:endParaRPr lang="en-US" sz="1300" dirty="0"/>
-          </a:p>
-        </p:txBody>
-      </p:sp>
-      <p:sp>
-        <p:nvSpPr>
-          <p:cNvPr id="24" name="Shape 21"/>
-          <p:cNvSpPr/>
-          <p:nvPr/>
-        </p:nvSpPr>
-        <p:spPr>
-          <a:xfrm>
+                <a:latin typeface="IBM Plex Sans"/>
+                <a:ea typeface="IBM Plex Sans"/>
+                <a:cs typeface="IBM Plex Sans"/>
+              </a:rPr>
+              <a:t>Ово је основа за контролну тачку КТ1 у термину Вежбе 4.</a:t>
+            </a:r>
+            <a:endParaRPr sz="1300"/>
+          </a:p>
+        </p:txBody>
+      </p:sp>
+      <p:sp>
+        <p:nvSpPr>
+          <p:cNvPr id="24" name="Shape 21">
+            <a:extLst xmlns:a="http://schemas.openxmlformats.org/drawingml/2006/main">
+              <a:ext uri="{FF2B5EF4-FFF2-40B4-BE49-F238E27FC236}">
+                <a16:creationId xmlns:a16="http://schemas.microsoft.com/office/drawing/2014/main" id="{9830A650-C8FD-4A56-A8D1-A2F8A4DEC647}"/>
+              </a:ext>
+            </a:extLst>
+          </p:cNvPr>
+          <p:cNvSpPr>
+            <a:spLocks xmlns:a="http://schemas.openxmlformats.org/drawingml/2006/main" noGrp="1"/>
+          </p:cNvSpPr>
+          <p:nvPr/>
+        </p:nvSpPr>
+        <p:spPr>
+          <a:xfrm xmlns:a="http://schemas.openxmlformats.org/drawingml/2006/main">
             <a:off x="812800" y="6209705"/>
             <a:ext cx="10566400" cy="0"/>
           </a:xfrm>
-          <a:prstGeom prst="line">
-            <a:avLst/>
-          </a:prstGeom>
-          <a:noFill/>
-          <a:ln w="6350">
+          <a:prstGeom xmlns:a="http://schemas.openxmlformats.org/drawingml/2006/main" prst="line">
+            <a:avLst/>
+          </a:prstGeom>
+          <a:noFill xmlns:a="http://schemas.openxmlformats.org/drawingml/2006/main"/>
+          <a:ln xmlns:a="http://schemas.openxmlformats.org/drawingml/2006/main" w="6350">
             <a:solidFill>
               <a:srgbClr val="D3DAE1"/>
             </a:solidFill>
@@ -38125,97 +38422,113 @@
       </p:sp>
       <p:sp>
         <p:nvSpPr>
-          <p:cNvPr id="25" name="Text 22"/>
-          <p:cNvSpPr/>
-          <p:nvPr/>
-        </p:nvSpPr>
-        <p:spPr>
-          <a:xfrm>
+          <p:cNvPr id="25" name="Text 22">
+            <a:extLst xmlns:a="http://schemas.openxmlformats.org/drawingml/2006/main">
+              <a:ext uri="{FF2B5EF4-FFF2-40B4-BE49-F238E27FC236}">
+                <a16:creationId xmlns:a16="http://schemas.microsoft.com/office/drawing/2014/main" id="{ECD44F5A-4F9B-4EB5-981E-E91D13FF97C2}"/>
+              </a:ext>
+            </a:extLst>
+          </p:cNvPr>
+          <p:cNvSpPr>
+            <a:spLocks xmlns:a="http://schemas.openxmlformats.org/drawingml/2006/main" noGrp="1"/>
+          </p:cNvSpPr>
+          <p:nvPr/>
+        </p:nvSpPr>
+        <p:spPr>
+          <a:xfrm xmlns:a="http://schemas.openxmlformats.org/drawingml/2006/main">
             <a:off x="812800" y="6314480"/>
             <a:ext cx="2390061" cy="238720"/>
           </a:xfrm>
-          <a:prstGeom prst="rect">
-            <a:avLst/>
-          </a:prstGeom>
-          <a:noFill/>
-          <a:ln/>
-        </p:spPr>
-        <p:txBody>
-          <a:bodyPr wrap="square" lIns="0" tIns="0" rIns="0" bIns="0" rtlCol="0" anchor="t">
-            <a:normAutofit/>
-          </a:bodyPr>
-          <a:lstStyle/>
-          <a:p>
-            <a:pPr algn="l" indent="0" marL="0">
+          <a:prstGeom xmlns:a="http://schemas.openxmlformats.org/drawingml/2006/main" prst="rect">
+            <a:avLst/>
+          </a:prstGeom>
+          <a:noFill xmlns:a="http://schemas.openxmlformats.org/drawingml/2006/main"/>
+        </p:spPr>
+        <p:txBody>
+          <a:bodyPr xmlns:a="http://schemas.openxmlformats.org/drawingml/2006/main" wrap="square" lIns="0" tIns="0" rIns="0" bIns="0" anchor="t">
+            <a:normAutofit/>
+          </a:bodyPr>
+          <a:lstStyle xmlns:a="http://schemas.openxmlformats.org/drawingml/2006/main"/>
+          <a:p xmlns:a="http://schemas.openxmlformats.org/drawingml/2006/main">
+            <a:pPr marL="0" indent="0" algn="l">
               <a:lnSpc>
                 <a:spcPts val="1680"/>
               </a:lnSpc>
               <a:buNone/>
             </a:pPr>
             <a:r>
-              <a:rPr lang="en-US" sz="1200" dirty="0">
+              <a:rPr sz="1200">
                 <a:solidFill>
                   <a:srgbClr val="5E6975"/>
                 </a:solidFill>
-                <a:latin typeface="IBM Plex Sans" pitchFamily="34" charset="0"/>
-                <a:ea typeface="IBM Plex Sans" pitchFamily="34" charset="-122"/>
-                <a:cs typeface="IBM Plex Sans" pitchFamily="34" charset="-120"/>
+                <a:latin typeface="IBM Plex Sans"/>
+                <a:ea typeface="IBM Plex Sans"/>
+                <a:cs typeface="IBM Plex Sans"/>
               </a:rPr>
               <a:t>Елементи развоја софтвера</a:t>
             </a:r>
-            <a:endParaRPr lang="en-US" sz="1200" dirty="0"/>
-          </a:p>
-        </p:txBody>
-      </p:sp>
-      <p:sp>
-        <p:nvSpPr>
-          <p:cNvPr id="26" name="Text 23"/>
-          <p:cNvSpPr/>
-          <p:nvPr/>
-        </p:nvSpPr>
-        <p:spPr>
-          <a:xfrm>
+            <a:endParaRPr sz="1200"/>
+          </a:p>
+        </p:txBody>
+      </p:sp>
+      <p:sp>
+        <p:nvSpPr>
+          <p:cNvPr id="26" name="Text 23">
+            <a:extLst xmlns:a="http://schemas.openxmlformats.org/drawingml/2006/main">
+              <a:ext uri="{FF2B5EF4-FFF2-40B4-BE49-F238E27FC236}">
+                <a16:creationId xmlns:a16="http://schemas.microsoft.com/office/drawing/2014/main" id="{7F77A75D-8044-42FB-9B00-918DC6253471}"/>
+              </a:ext>
+            </a:extLst>
+          </p:cNvPr>
+          <p:cNvSpPr>
+            <a:spLocks xmlns:a="http://schemas.openxmlformats.org/drawingml/2006/main" noGrp="1"/>
+          </p:cNvSpPr>
+          <p:nvPr/>
+        </p:nvSpPr>
+        <p:spPr>
+          <a:xfrm xmlns:a="http://schemas.openxmlformats.org/drawingml/2006/main">
             <a:off x="11145441" y="6314480"/>
             <a:ext cx="233759" cy="238720"/>
           </a:xfrm>
-          <a:prstGeom prst="rect">
-            <a:avLst/>
-          </a:prstGeom>
-          <a:noFill/>
-          <a:ln/>
-        </p:spPr>
-        <p:txBody>
-          <a:bodyPr wrap="square" lIns="0" tIns="0" rIns="0" bIns="0" rtlCol="0" anchor="t">
-            <a:normAutofit/>
-          </a:bodyPr>
-          <a:lstStyle/>
-          <a:p>
-            <a:pPr algn="r" indent="0" marL="0">
+          <a:prstGeom xmlns:a="http://schemas.openxmlformats.org/drawingml/2006/main" prst="rect">
+            <a:avLst/>
+          </a:prstGeom>
+          <a:noFill xmlns:a="http://schemas.openxmlformats.org/drawingml/2006/main"/>
+        </p:spPr>
+        <p:txBody>
+          <a:bodyPr xmlns:a="http://schemas.openxmlformats.org/drawingml/2006/main" wrap="square" lIns="0" tIns="0" rIns="0" bIns="0" anchor="t">
+            <a:normAutofit/>
+          </a:bodyPr>
+          <a:lstStyle xmlns:a="http://schemas.openxmlformats.org/drawingml/2006/main"/>
+          <a:p xmlns:a="http://schemas.openxmlformats.org/drawingml/2006/main">
+            <a:pPr marL="0" indent="0" algn="r">
               <a:lnSpc>
                 <a:spcPts val="1680"/>
               </a:lnSpc>
               <a:buNone/>
             </a:pPr>
             <a:r>
-              <a:rPr lang="en-US" sz="1200" dirty="0">
+              <a:rPr sz="1200">
                 <a:solidFill>
                   <a:srgbClr val="5E6975"/>
                 </a:solidFill>
-                <a:latin typeface="IBM Plex Mono" pitchFamily="49" charset="0"/>
-                <a:ea typeface="IBM Plex Mono" pitchFamily="49" charset="-122"/>
-                <a:cs typeface="IBM Plex Mono" pitchFamily="49" charset="-120"/>
+                <a:latin typeface="IBM Plex Mono"/>
+                <a:ea typeface="IBM Plex Mono"/>
+                <a:cs typeface="IBM Plex Mono"/>
               </a:rPr>
               <a:t>37</a:t>
             </a:r>
-            <a:endParaRPr lang="en-US" sz="1200" dirty="0"/>
+            <a:endParaRPr sz="1200"/>
           </a:p>
         </p:txBody>
       </p:sp>
     </p:spTree>
+    <p:extLst>
+      <p:ext uri="{BB962C8B-B14F-4D97-AF65-F5344CB8AC3E}">
+        <p14:creationId xmlns:p14="http://schemas.microsoft.com/office/powerpoint/2010/main" val="1214779678"/>
+      </p:ext>
+    </p:extLst>
   </p:cSld>
-  <p:clrMapOvr>
-    <a:masterClrMapping/>
-  </p:clrMapOvr>
 </p:sld>
 </file>
 

</xml_diff>